<commit_message>
Whirlpool v4.1: fee mediowe w budżecie, nowy slajd podsumowania kosztów, ruch jakościowy, disclaimer Meta
- Slajd 'Budżet całkowity': wiersz fee mediowe 15% (45 tys. zł), RAZEM 867 tys. zł netto
- Nowy slajd 'Podsumowanie kosztów akcji': budka+meble, media z fee, kreacja i obsługa, LP, content, fee agencyjne 10% od kosztów zewnętrznych – RAZEM 693-696,3 tys. zł netto
- Rozdzielony i zaakcentowany ruch jakościowy (15,9 tys. Search+Meta) na slajdach KPI i rozbicia kosztów
- Disclaimer przy stawkach Meta poniżej benchmarku

Co-Authored-By: Claude Fable 5 <noreply@anthropic.com>
Claude-Session: https://claude.ai/code/session_01E5DGDjrPAHRmvjYBvQaqLi
</commit_message>
<xml_diff>
--- a/prezentacje/whirlpool/CISZAWHP_dla_CZ_O_OK_v4.1.pptx
+++ b/prezentacje/whirlpool/CISZAWHP_dla_CZ_O_OK_v4.1.pptx
@@ -28,6 +28,7 @@
     <p:sldId id="303" r:id="rId22"/>
     <p:sldId id="304" r:id="rId23"/>
     <p:sldId id="305" r:id="rId24"/>
+    <p:sldId id="310" r:id="rId30"/>
     <p:sldId id="290" r:id="rId25"/>
   </p:sldIdLst>
   <p:sldSz cx="12192000" cy="6858000"/>
@@ -16282,7 +16283,7 @@
                           <a:ea typeface="Calibri" pitchFamily="34" charset="-122"/>
                           <a:cs typeface="Calibri" pitchFamily="34" charset="-120"/>
                         </a:rPr>
-                        <a:t>5,50–7,00 zł</a:t>
+                        <a:t>5,50–7,00 zł*</a:t>
                       </a:r>
                       <a:endParaRPr lang="en-US" sz="1000" dirty="0">
                         <a:latin typeface="Calibri" charset="0"/>
@@ -18190,7 +18191,7 @@
                 <a:ea typeface="Calibri" pitchFamily="34" charset="-122"/>
                 <a:cs typeface="Calibri" pitchFamily="34" charset="-120"/>
               </a:rPr>
-              <a:t>mediany stawek kampanii zasięgowych AGD / dom i wnętrze w Polsce (2025–2026). Rynek polski jest 40–60% tańszy od średnich globalnych (globalny CPM: Meta ~8 USD, TikTok ~5 USD, YouTube ~5 USD), co czyni zakładane koszty dotarcia realistycznymi i możliwymi do obrony w realizacji.</a:t>
+              <a:t>mediany stawek kampanii zasięgowych AGD / dom i wnętrze w Polsce (2025–2026). Rynek polski jest 40–60% tańszy od średnich globalnych (globalny CPM: Meta ~8 USD, TikTok ~5 USD, YouTube ~5 USD), co czyni zakładane koszty dotarcia realistycznymi i możliwymi do obrony w realizacji.  *Disclaimer – Meta: stawka przyjęta poniżej dolnej granicy benchmarku (8–14 zł); zakłada szerokie grupy zasięgowe i formaty Reels. W szczycie Q4 (Black Friday) CPM Meta może wzrosnąć – wówczas realokujemy budżet na bieżąco do tańszych kanałów (TikTok, GDN), chroniąc łączny wolumen odsłon.</a:t>
             </a:r>
             <a:endParaRPr lang="en-US" sz="1000" dirty="0"/>
           </a:p>
@@ -25188,7 +25189,7 @@
                 <a:ea typeface="Calibri" pitchFamily="34" charset="-122"/>
                 <a:cs typeface="Calibri" pitchFamily="34" charset="-120"/>
               </a:rPr>
-              <a:t>Kliknięcia łącznie: </a:t>
+              <a:t>Ruch jakościowy – 15,9 tys. kliknięć: </a:t>
             </a:r>
             <a:r>
               <a:rPr lang="en-US" sz="1000" dirty="0">
@@ -25199,7 +25200,7 @@
                 <a:ea typeface="Calibri" pitchFamily="34" charset="-122"/>
                 <a:cs typeface="Calibri" pitchFamily="34" charset="-120"/>
               </a:rPr>
-              <a:t>58,8 tys. z kampanii performance i remarketingu (Search, Meta, GDN) + ~12,7 tys. z formatów zasięgowych = 71,5 tys. przejść do stron produktowych Whirlpool.</a:t>
+              <a:t>Google Search (7,5 tys.) + Meta performance (8,4 tys.) – kliknięcia z realną intencją zakupową, którymi mierzymy efekt sprzedażowy. Pozostałe 55,6 tys. (GDN + formaty zasięgowe) buduje skalę i zasila remarketing. Łącznie: 71,5 tys. przejść do stron produktowych.</a:t>
             </a:r>
             <a:endParaRPr lang="en-US" sz="1000" dirty="0"/>
           </a:p>
@@ -25869,7 +25870,7 @@
                 <a:ea typeface="Calibri" pitchFamily="34" charset="-122"/>
                 <a:cs typeface="Calibri" pitchFamily="34" charset="-120"/>
               </a:rPr>
-              <a:t>kliknięć do stron produktowych</a:t>
+              <a:t>kliknięć łącznie – w tym 15,9 tys. jakościowych (Search + Meta)</a:t>
             </a:r>
             <a:endParaRPr lang="en-US" sz="950" dirty="0"/>
           </a:p>
@@ -28356,6 +28357,285 @@
                           <a:ea typeface="Calibri" pitchFamily="34" charset="-122"/>
                           <a:cs typeface="Calibri" pitchFamily="34" charset="-120"/>
                         </a:rPr>
+                        <a:t>Fee mediowe – 15% budżetu digital</a:t>
+                      </a:r>
+                      <a:endParaRPr lang="en-US" sz="950" dirty="0">
+                        <a:latin typeface="Calibri" charset="0"/>
+                        <a:ea typeface="Calibri" charset="0"/>
+                        <a:cs typeface="Calibri" charset="0"/>
+                      </a:endParaRPr>
+                    </a:p>
+                  </a:txBody>
+                  <a:tcPr marL="64008" marR="64008" marT="64008" marB="64008" anchor="ctr">
+                    <a:lnL w="6350" cap="flat" cmpd="sng" algn="ctr">
+                      <a:solidFill>
+                        <a:srgbClr val="E0E0DC"/>
+                      </a:solidFill>
+                      <a:prstDash val="solid"/>
+                      <a:round/>
+                      <a:headEnd type="none" w="med" len="med"/>
+                      <a:tailEnd type="none" w="med" len="med"/>
+                    </a:lnL>
+                    <a:lnR w="6350" cap="flat" cmpd="sng" algn="ctr">
+                      <a:solidFill>
+                        <a:srgbClr val="E0E0DC"/>
+                      </a:solidFill>
+                      <a:prstDash val="solid"/>
+                      <a:round/>
+                      <a:headEnd type="none" w="med" len="med"/>
+                      <a:tailEnd type="none" w="med" len="med"/>
+                    </a:lnR>
+                    <a:lnT w="6350" cap="flat" cmpd="sng" algn="ctr">
+                      <a:solidFill>
+                        <a:srgbClr val="E0E0DC"/>
+                      </a:solidFill>
+                      <a:prstDash val="solid"/>
+                      <a:round/>
+                      <a:headEnd type="none" w="med" len="med"/>
+                      <a:tailEnd type="none" w="med" len="med"/>
+                    </a:lnT>
+                    <a:lnB w="6350" cap="flat" cmpd="sng" algn="ctr">
+                      <a:solidFill>
+                        <a:srgbClr val="E0E0DC"/>
+                      </a:solidFill>
+                      <a:prstDash val="solid"/>
+                      <a:round/>
+                      <a:headEnd type="none" w="med" len="med"/>
+                      <a:tailEnd type="none" w="med" len="med"/>
+                    </a:lnB>
+                    <a:solidFill>
+                      <a:srgbClr val="FFFFFF"/>
+                    </a:solidFill>
+                  </a:tcPr>
+                </a:tc>
+                <a:tc>
+                  <a:txBody>
+                    <a:bodyPr/>
+                    <a:lstStyle/>
+                    <a:p>
+                      <a:pPr marL="0" indent="0" algn="ctr">
+                        <a:buNone/>
+                      </a:pPr>
+                      <a:r>
+                        <a:rPr lang="en-US" sz="950" dirty="0">
+                          <a:solidFill>
+                            <a:srgbClr val="4D4D4D"/>
+                          </a:solidFill>
+                          <a:latin typeface="Calibri" pitchFamily="34" charset="0"/>
+                          <a:ea typeface="Calibri" pitchFamily="34" charset="-122"/>
+                          <a:cs typeface="Calibri" pitchFamily="34" charset="-120"/>
+                        </a:rPr>
+                        <a:t>—</a:t>
+                      </a:r>
+                      <a:endParaRPr lang="en-US" sz="950" dirty="0">
+                        <a:latin typeface="Calibri" charset="0"/>
+                        <a:ea typeface="Calibri" charset="0"/>
+                        <a:cs typeface="Calibri" charset="0"/>
+                      </a:endParaRPr>
+                    </a:p>
+                  </a:txBody>
+                  <a:tcPr marL="64008" marR="64008" marT="64008" marB="64008" anchor="ctr">
+                    <a:lnL w="6350" cap="flat" cmpd="sng" algn="ctr">
+                      <a:solidFill>
+                        <a:srgbClr val="E0E0DC"/>
+                      </a:solidFill>
+                      <a:prstDash val="solid"/>
+                      <a:round/>
+                      <a:headEnd type="none" w="med" len="med"/>
+                      <a:tailEnd type="none" w="med" len="med"/>
+                    </a:lnL>
+                    <a:lnR w="6350" cap="flat" cmpd="sng" algn="ctr">
+                      <a:solidFill>
+                        <a:srgbClr val="E0E0DC"/>
+                      </a:solidFill>
+                      <a:prstDash val="solid"/>
+                      <a:round/>
+                      <a:headEnd type="none" w="med" len="med"/>
+                      <a:tailEnd type="none" w="med" len="med"/>
+                    </a:lnR>
+                    <a:lnT w="6350" cap="flat" cmpd="sng" algn="ctr">
+                      <a:solidFill>
+                        <a:srgbClr val="E0E0DC"/>
+                      </a:solidFill>
+                      <a:prstDash val="solid"/>
+                      <a:round/>
+                      <a:headEnd type="none" w="med" len="med"/>
+                      <a:tailEnd type="none" w="med" len="med"/>
+                    </a:lnT>
+                    <a:lnB w="6350" cap="flat" cmpd="sng" algn="ctr">
+                      <a:solidFill>
+                        <a:srgbClr val="E0E0DC"/>
+                      </a:solidFill>
+                      <a:prstDash val="solid"/>
+                      <a:round/>
+                      <a:headEnd type="none" w="med" len="med"/>
+                      <a:tailEnd type="none" w="med" len="med"/>
+                    </a:lnB>
+                    <a:solidFill>
+                      <a:srgbClr val="FFFFFF"/>
+                    </a:solidFill>
+                  </a:tcPr>
+                </a:tc>
+                <a:tc>
+                  <a:txBody>
+                    <a:bodyPr/>
+                    <a:lstStyle/>
+                    <a:p>
+                      <a:pPr marL="0" indent="0" algn="ctr">
+                        <a:buNone/>
+                      </a:pPr>
+                      <a:r>
+                        <a:rPr lang="en-US" sz="950" b="1" dirty="0">
+                          <a:solidFill>
+                            <a:srgbClr val="4D4D4D"/>
+                          </a:solidFill>
+                          <a:latin typeface="Calibri" pitchFamily="34" charset="0"/>
+                          <a:ea typeface="Calibri" pitchFamily="34" charset="-122"/>
+                          <a:cs typeface="Calibri" pitchFamily="34" charset="-120"/>
+                        </a:rPr>
+                        <a:t>45 000 zł</a:t>
+                      </a:r>
+                      <a:endParaRPr lang="en-US" sz="950" dirty="0">
+                        <a:latin typeface="Calibri" charset="0"/>
+                        <a:ea typeface="Calibri" charset="0"/>
+                        <a:cs typeface="Calibri" charset="0"/>
+                      </a:endParaRPr>
+                    </a:p>
+                  </a:txBody>
+                  <a:tcPr marL="64008" marR="64008" marT="64008" marB="64008" anchor="ctr">
+                    <a:lnL w="6350" cap="flat" cmpd="sng" algn="ctr">
+                      <a:solidFill>
+                        <a:srgbClr val="E0E0DC"/>
+                      </a:solidFill>
+                      <a:prstDash val="solid"/>
+                      <a:round/>
+                      <a:headEnd type="none" w="med" len="med"/>
+                      <a:tailEnd type="none" w="med" len="med"/>
+                    </a:lnL>
+                    <a:lnR w="6350" cap="flat" cmpd="sng" algn="ctr">
+                      <a:solidFill>
+                        <a:srgbClr val="E0E0DC"/>
+                      </a:solidFill>
+                      <a:prstDash val="solid"/>
+                      <a:round/>
+                      <a:headEnd type="none" w="med" len="med"/>
+                      <a:tailEnd type="none" w="med" len="med"/>
+                    </a:lnR>
+                    <a:lnT w="6350" cap="flat" cmpd="sng" algn="ctr">
+                      <a:solidFill>
+                        <a:srgbClr val="E0E0DC"/>
+                      </a:solidFill>
+                      <a:prstDash val="solid"/>
+                      <a:round/>
+                      <a:headEnd type="none" w="med" len="med"/>
+                      <a:tailEnd type="none" w="med" len="med"/>
+                    </a:lnT>
+                    <a:lnB w="6350" cap="flat" cmpd="sng" algn="ctr">
+                      <a:solidFill>
+                        <a:srgbClr val="E0E0DC"/>
+                      </a:solidFill>
+                      <a:prstDash val="solid"/>
+                      <a:round/>
+                      <a:headEnd type="none" w="med" len="med"/>
+                      <a:tailEnd type="none" w="med" len="med"/>
+                    </a:lnB>
+                    <a:solidFill>
+                      <a:srgbClr val="FFFFFF"/>
+                    </a:solidFill>
+                  </a:tcPr>
+                </a:tc>
+                <a:tc>
+                  <a:txBody>
+                    <a:bodyPr/>
+                    <a:lstStyle/>
+                    <a:p>
+                      <a:pPr marL="0" indent="0" algn="l">
+                        <a:buNone/>
+                      </a:pPr>
+                      <a:r>
+                        <a:rPr lang="en-US" sz="950" dirty="0">
+                          <a:solidFill>
+                            <a:srgbClr val="4D4D4D"/>
+                          </a:solidFill>
+                          <a:latin typeface="Calibri" pitchFamily="34" charset="0"/>
+                          <a:ea typeface="Calibri" pitchFamily="34" charset="-122"/>
+                          <a:cs typeface="Calibri" pitchFamily="34" charset="-120"/>
+                        </a:rPr>
+                        <a:t>setup, prowadzenie i optymalizacja kampanii, raportowanie</a:t>
+                      </a:r>
+                      <a:endParaRPr lang="en-US" sz="950" dirty="0">
+                        <a:latin typeface="Calibri" charset="0"/>
+                        <a:ea typeface="Calibri" charset="0"/>
+                        <a:cs typeface="Calibri" charset="0"/>
+                      </a:endParaRPr>
+                    </a:p>
+                  </a:txBody>
+                  <a:tcPr marL="64008" marR="64008" marT="64008" marB="64008" anchor="ctr">
+                    <a:lnL w="6350" cap="flat" cmpd="sng" algn="ctr">
+                      <a:solidFill>
+                        <a:srgbClr val="E0E0DC"/>
+                      </a:solidFill>
+                      <a:prstDash val="solid"/>
+                      <a:round/>
+                      <a:headEnd type="none" w="med" len="med"/>
+                      <a:tailEnd type="none" w="med" len="med"/>
+                    </a:lnL>
+                    <a:lnR w="6350" cap="flat" cmpd="sng" algn="ctr">
+                      <a:solidFill>
+                        <a:srgbClr val="E0E0DC"/>
+                      </a:solidFill>
+                      <a:prstDash val="solid"/>
+                      <a:round/>
+                      <a:headEnd type="none" w="med" len="med"/>
+                      <a:tailEnd type="none" w="med" len="med"/>
+                    </a:lnR>
+                    <a:lnT w="6350" cap="flat" cmpd="sng" algn="ctr">
+                      <a:solidFill>
+                        <a:srgbClr val="E0E0DC"/>
+                      </a:solidFill>
+                      <a:prstDash val="solid"/>
+                      <a:round/>
+                      <a:headEnd type="none" w="med" len="med"/>
+                      <a:tailEnd type="none" w="med" len="med"/>
+                    </a:lnT>
+                    <a:lnB w="6350" cap="flat" cmpd="sng" algn="ctr">
+                      <a:solidFill>
+                        <a:srgbClr val="E0E0DC"/>
+                      </a:solidFill>
+                      <a:prstDash val="solid"/>
+                      <a:round/>
+                      <a:headEnd type="none" w="med" len="med"/>
+                      <a:tailEnd type="none" w="med" len="med"/>
+                    </a:lnB>
+                    <a:solidFill>
+                      <a:srgbClr val="FFFFFF"/>
+                    </a:solidFill>
+                  </a:tcPr>
+                </a:tc>
+                <a:extLst>
+                  <a:ext uri="{0D108BD9-81ED-4DB2-BD59-A6C34878D82A}">
+                    <a16:rowId xmlns:a16="http://schemas.microsoft.com/office/drawing/2014/main" val="10005"/>
+                  </a:ext>
+                </a:extLst>
+              </a:tr>
+              <a:tr h="457200">
+                <a:tc>
+                  <a:txBody>
+                    <a:bodyPr/>
+                    <a:lstStyle/>
+                    <a:p>
+                      <a:pPr marL="0" indent="0" algn="l">
+                        <a:buNone/>
+                      </a:pPr>
+                      <a:r>
+                        <a:rPr lang="en-US" sz="950" b="1" dirty="0">
+                          <a:solidFill>
+                            <a:srgbClr val="111111"/>
+                          </a:solidFill>
+                          <a:latin typeface="Calibri" pitchFamily="34" charset="0"/>
+                          <a:ea typeface="Calibri" pitchFamily="34" charset="-122"/>
+                          <a:cs typeface="Calibri" pitchFamily="34" charset="-120"/>
+                        </a:rPr>
                         <a:t>RAZEM (netto)</a:t>
                       </a:r>
                       <a:endParaRPr lang="en-US" sz="950" dirty="0">
@@ -28424,7 +28704,7 @@
                           <a:ea typeface="Calibri" pitchFamily="34" charset="-122"/>
                           <a:cs typeface="Calibri" pitchFamily="34" charset="-120"/>
                         </a:rPr>
-                        <a:t>445,8–905,4 tys. zł</a:t>
+                        <a:t>490,8–950,4 tys. zł</a:t>
                       </a:r>
                       <a:endParaRPr lang="en-US" sz="950" dirty="0">
                         <a:latin typeface="Calibri" charset="0"/>
@@ -28492,7 +28772,7 @@
                           <a:ea typeface="Calibri" pitchFamily="34" charset="-122"/>
                           <a:cs typeface="Calibri" pitchFamily="34" charset="-120"/>
                         </a:rPr>
-                        <a:t>822 000 zł</a:t>
+                        <a:t>867 000 zł</a:t>
                       </a:r>
                       <a:endParaRPr lang="en-US" sz="950" dirty="0">
                         <a:latin typeface="Calibri" charset="0"/>
@@ -28618,8 +28898,8 @@
         </p:nvSpPr>
         <p:spPr>
           <a:xfrm>
-            <a:off x="1691640" y="5074920"/>
-            <a:ext cx="9692640" cy="1234440"/>
+            <a:off x="1691640" y="5394960"/>
+            <a:ext cx="9692640" cy="1280160"/>
           </a:xfrm>
           <a:prstGeom prst="roundRect">
             <a:avLst>
@@ -28647,8 +28927,8 @@
         </p:nvSpPr>
         <p:spPr>
           <a:xfrm>
-            <a:off x="1874520" y="5166360"/>
-            <a:ext cx="9326880" cy="1051560"/>
+            <a:off x="1874520" y="5486400"/>
+            <a:ext cx="9326880" cy="1097280"/>
           </a:xfrm>
           <a:prstGeom prst="rect">
             <a:avLst/>
@@ -28683,7 +28963,7 @@
                 <a:ea typeface="Calibri" pitchFamily="34" charset="-122"/>
                 <a:cs typeface="Calibri" pitchFamily="34" charset="-120"/>
               </a:rPr>
-              <a:t>Poprzednie materiały zestawiały widełki produkcyjne (rozpiętość ~160 tys. zł) z dwoma scenariuszami mediowymi (200 i 500 tys. zł), co dawało łączny rozrzut w przeliczeniu na euro rzędu 50 tys. €. Powyższa tabela zamyka każdą pozycję jedną rekomendowaną kwotą – łączny budżet kampanii to 822 tys. zł netto, z czego 500 tys. zł stanowią media gwarantujące mierzalny zasięg 5,2 mln osób.</a:t>
+              <a:t>Poprzednie materiały zestawiały widełki produkcyjne (rozpiętość ~160 tys. zł) z dwoma scenariuszami mediowymi (200 i 500 tys. zł), co dawało łączny rozrzut w przeliczeniu na euro rzędu 50 tys. €. Powyższa tabela zamyka każdą pozycję jedną rekomendowaną kwotą – łączny budżet kampanii to 867 tys. zł netto (z fee mediowym), z czego 545 tys. zł stanowią media wraz z fee, gwarantujące mierzalny zasięg 5,2 mln osób.</a:t>
             </a:r>
             <a:endParaRPr lang="en-US" sz="1000" dirty="0"/>
           </a:p>
@@ -29136,6 +29416,3768 @@
         <p14:creationId xmlns:p14="http://schemas.microsoft.com/office/powerpoint/2010/main" val="1201653385"/>
       </p:ext>
     </p:extLst>
+  </p:cSld>
+  <p:clrMapOvr>
+    <a:masterClrMapping/>
+  </p:clrMapOvr>
+</p:sld>
+</file>
+
+<file path=ppt/slides/slide25.xml><?xml version="1.0" encoding="utf-8"?>
+<p:sld xmlns:a="http://schemas.openxmlformats.org/drawingml/2006/main" xmlns:r="http://schemas.openxmlformats.org/officeDocument/2006/relationships" xmlns:p="http://schemas.openxmlformats.org/presentationml/2006/main">
+  <p:cSld name="Slide 10">
+    <p:bg>
+      <p:bgPr>
+        <a:solidFill>
+          <a:srgbClr val="FFFFFF"/>
+        </a:solidFill>
+        <a:effectLst/>
+      </p:bgPr>
+    </p:bg>
+    <p:spTree>
+      <p:nvGrpSpPr>
+        <p:cNvPr id="1" name=""/>
+        <p:cNvGrpSpPr/>
+        <p:nvPr/>
+      </p:nvGrpSpPr>
+      <p:grpSpPr>
+        <a:xfrm>
+          <a:off x="0" y="0"/>
+          <a:ext cx="0" cy="0"/>
+          <a:chOff x="0" y="0"/>
+          <a:chExt cx="0" cy="0"/>
+        </a:xfrm>
+      </p:grpSpPr>
+      <p:pic>
+        <p:nvPicPr>
+          <p:cNvPr id="2" name="Image 0" descr="asset_strip.jpg"/>
+          <p:cNvPicPr>
+            <a:picLocks noChangeAspect="1"/>
+          </p:cNvPicPr>
+          <p:nvPr/>
+        </p:nvPicPr>
+        <p:blipFill>
+          <a:blip r:embed="rId2"/>
+          <a:stretch>
+            <a:fillRect/>
+          </a:stretch>
+        </p:blipFill>
+        <p:spPr>
+          <a:xfrm>
+            <a:off x="0" y="0"/>
+            <a:ext cx="1408176" cy="6858000"/>
+          </a:xfrm>
+          <a:prstGeom prst="rect">
+            <a:avLst/>
+          </a:prstGeom>
+        </p:spPr>
+      </p:pic>
+      <p:pic>
+        <p:nvPicPr>
+          <p:cNvPr id="3" name="Image 1" descr="asset_logo_box.png"/>
+          <p:cNvPicPr>
+            <a:picLocks noChangeAspect="1"/>
+          </p:cNvPicPr>
+          <p:nvPr/>
+        </p:nvPicPr>
+        <p:blipFill>
+          <a:blip r:embed="rId3"/>
+          <a:stretch>
+            <a:fillRect/>
+          </a:stretch>
+        </p:blipFill>
+        <p:spPr>
+          <a:xfrm>
+            <a:off x="210312" y="256032"/>
+            <a:ext cx="987552" cy="978408"/>
+          </a:xfrm>
+          <a:prstGeom prst="rect">
+            <a:avLst/>
+          </a:prstGeom>
+        </p:spPr>
+      </p:pic>
+      <p:sp>
+        <p:nvSpPr>
+          <p:cNvPr id="4" name="Text 0"/>
+          <p:cNvSpPr/>
+          <p:nvPr/>
+        </p:nvSpPr>
+        <p:spPr>
+          <a:xfrm>
+            <a:off x="1691640" y="365760"/>
+            <a:ext cx="2103120" cy="292608"/>
+          </a:xfrm>
+          <a:prstGeom prst="rect">
+            <a:avLst/>
+          </a:prstGeom>
+          <a:solidFill>
+            <a:srgbClr val="F5C800"/>
+          </a:solidFill>
+          <a:ln/>
+        </p:spPr>
+        <p:txBody>
+          <a:bodyPr wrap="square" lIns="0" tIns="0" rIns="0" bIns="0" rtlCol="0" anchor="ctr"/>
+          <a:lstStyle/>
+          <a:p>
+            <a:pPr marL="0" indent="0" algn="ctr">
+              <a:buNone/>
+            </a:pPr>
+            <a:r>
+              <a:rPr lang="en-US" sz="800" kern="0" spc="200" dirty="0">
+                <a:solidFill>
+                  <a:srgbClr val="111111"/>
+                </a:solidFill>
+                <a:latin typeface="Arial Black" pitchFamily="34" charset="0"/>
+                <a:ea typeface="Arial Black" pitchFamily="34" charset="-122"/>
+                <a:cs typeface="Arial Black" pitchFamily="34" charset="-120"/>
+              </a:rPr>
+              <a:t>LINIA 01</a:t>
+            </a:r>
+            <a:endParaRPr lang="en-US" sz="800" dirty="0"/>
+          </a:p>
+        </p:txBody>
+      </p:sp>
+      <p:sp>
+        <p:nvSpPr>
+          <p:cNvPr id="5" name="Text 1"/>
+          <p:cNvSpPr/>
+          <p:nvPr/>
+        </p:nvSpPr>
+        <p:spPr>
+          <a:xfrm>
+            <a:off x="1691640" y="749808"/>
+            <a:ext cx="10058400" cy="502920"/>
+          </a:xfrm>
+          <a:prstGeom prst="rect">
+            <a:avLst/>
+          </a:prstGeom>
+          <a:noFill/>
+          <a:ln/>
+        </p:spPr>
+        <p:txBody>
+          <a:bodyPr wrap="square" lIns="0" tIns="0" rIns="0" bIns="0" rtlCol="0" anchor="ctr"/>
+          <a:lstStyle/>
+          <a:p>
+            <a:pPr marL="0" indent="0">
+              <a:buNone/>
+            </a:pPr>
+            <a:r>
+              <a:rPr lang="en-US" sz="1800" dirty="0">
+                <a:solidFill>
+                  <a:srgbClr val="111111"/>
+                </a:solidFill>
+                <a:latin typeface="Arial Black" pitchFamily="34" charset="0"/>
+                <a:ea typeface="Arial Black" pitchFamily="34" charset="-122"/>
+                <a:cs typeface="Arial Black" pitchFamily="34" charset="-120"/>
+              </a:rPr>
+              <a:t>Podsumowanie kosztów akcji</a:t>
+            </a:r>
+            <a:endParaRPr lang="en-US" sz="1800" dirty="0"/>
+          </a:p>
+        </p:txBody>
+      </p:sp>
+      <p:graphicFrame>
+        <p:nvGraphicFramePr>
+          <p:cNvPr id="11" name="Table 0"/>
+          <p:cNvGraphicFramePr>
+            <a:graphicFrameLocks noGrp="1"/>
+          </p:cNvGraphicFramePr>
+          <p:nvPr>
+            <p:extLst>
+              <p:ext uri="{D42A27DB-BD31-4B8C-83A1-F6EECF244321}">
+                <p14:modId xmlns:p14="http://schemas.microsoft.com/office/powerpoint/2010/main" val="1579011935"/>
+              </p:ext>
+            </p:extLst>
+          </p:nvPr>
+        </p:nvGraphicFramePr>
+        <p:xfrm>
+          <a:off x="1691640" y="1257300"/>
+          <a:ext cx="9692640" cy="3200400"/>
+        </p:xfrm>
+        <a:graphic>
+          <a:graphicData uri="http://schemas.openxmlformats.org/drawingml/2006/table">
+            <a:tbl>
+              <a:tblPr/>
+              <a:tblGrid>
+                <a:gridCol w="3657600"/>
+                <a:gridCol w="1600200"/>
+                <a:gridCol w="4434840"/>
+              </a:tblGrid>
+              <a:tr h="365760">
+                <a:tc>
+                  <a:txBody>
+                    <a:bodyPr/>
+                    <a:lstStyle/>
+                    <a:p>
+                      <a:pPr marL="0" indent="0" algn="l">
+                        <a:buNone/>
+                      </a:pPr>
+                      <a:r>
+                        <a:rPr lang="en-US" sz="950" b="1" dirty="0">
+                          <a:solidFill>
+                            <a:srgbClr val="FFFFFF"/>
+                          </a:solidFill>
+                          <a:latin typeface="Calibri" pitchFamily="34" charset="0"/>
+                          <a:ea typeface="Calibri" pitchFamily="34" charset="-122"/>
+                          <a:cs typeface="Calibri" pitchFamily="34" charset="-120"/>
+                        </a:rPr>
+                        <a:t>Pozycja</a:t>
+                      </a:r>
+                      <a:endParaRPr lang="en-US" sz="950" dirty="0">
+                        <a:latin typeface="Calibri" charset="0"/>
+                        <a:ea typeface="Calibri" charset="0"/>
+                        <a:cs typeface="Calibri" charset="0"/>
+                      </a:endParaRPr>
+                    </a:p>
+                  </a:txBody>
+                  <a:tcPr marL="64008" marR="64008" marT="27432" marB="27432" anchor="ctr">
+                    <a:lnL w="6350" cap="flat" cmpd="sng" algn="ctr">
+                      <a:solidFill>
+                        <a:srgbClr val="E0E0DC"/>
+                      </a:solidFill>
+                      <a:prstDash val="solid"/>
+                      <a:round/>
+                      <a:headEnd type="none" w="med" len="med"/>
+                      <a:tailEnd type="none" w="med" len="med"/>
+                    </a:lnL>
+                    <a:lnR w="6350" cap="flat" cmpd="sng" algn="ctr">
+                      <a:solidFill>
+                        <a:srgbClr val="E0E0DC"/>
+                      </a:solidFill>
+                      <a:prstDash val="solid"/>
+                      <a:round/>
+                      <a:headEnd type="none" w="med" len="med"/>
+                      <a:tailEnd type="none" w="med" len="med"/>
+                    </a:lnR>
+                    <a:lnT w="6350" cap="flat" cmpd="sng" algn="ctr">
+                      <a:solidFill>
+                        <a:srgbClr val="E0E0DC"/>
+                      </a:solidFill>
+                      <a:prstDash val="solid"/>
+                      <a:round/>
+                      <a:headEnd type="none" w="med" len="med"/>
+                      <a:tailEnd type="none" w="med" len="med"/>
+                    </a:lnT>
+                    <a:lnB w="6350" cap="flat" cmpd="sng" algn="ctr">
+                      <a:solidFill>
+                        <a:srgbClr val="E0E0DC"/>
+                      </a:solidFill>
+                      <a:prstDash val="solid"/>
+                      <a:round/>
+                      <a:headEnd type="none" w="med" len="med"/>
+                      <a:tailEnd type="none" w="med" len="med"/>
+                    </a:lnB>
+                    <a:solidFill>
+                      <a:srgbClr val="111111"/>
+                    </a:solidFill>
+                  </a:tcPr>
+                </a:tc>
+                <a:tc>
+                  <a:txBody>
+                    <a:bodyPr/>
+                    <a:lstStyle/>
+                    <a:p>
+                      <a:pPr marL="0" indent="0" algn="ctr">
+                        <a:buNone/>
+                      </a:pPr>
+                      <a:r>
+                        <a:rPr lang="en-US" sz="950" b="1" dirty="0">
+                          <a:solidFill>
+                            <a:srgbClr val="FFFFFF"/>
+                          </a:solidFill>
+                          <a:latin typeface="Calibri" pitchFamily="34" charset="0"/>
+                          <a:ea typeface="Calibri" pitchFamily="34" charset="-122"/>
+                          <a:cs typeface="Calibri" pitchFamily="34" charset="-120"/>
+                        </a:rPr>
+                        <a:t>Koszt netto</a:t>
+                      </a:r>
+                      <a:endParaRPr lang="en-US" sz="950" dirty="0">
+                        <a:latin typeface="Calibri" charset="0"/>
+                        <a:ea typeface="Calibri" charset="0"/>
+                        <a:cs typeface="Calibri" charset="0"/>
+                      </a:endParaRPr>
+                    </a:p>
+                  </a:txBody>
+                  <a:tcPr marL="64008" marR="64008" marT="27432" marB="27432" anchor="ctr">
+                    <a:lnL w="6350" cap="flat" cmpd="sng" algn="ctr">
+                      <a:solidFill>
+                        <a:srgbClr val="E0E0DC"/>
+                      </a:solidFill>
+                      <a:prstDash val="solid"/>
+                      <a:round/>
+                      <a:headEnd type="none" w="med" len="med"/>
+                      <a:tailEnd type="none" w="med" len="med"/>
+                    </a:lnL>
+                    <a:lnR w="6350" cap="flat" cmpd="sng" algn="ctr">
+                      <a:solidFill>
+                        <a:srgbClr val="E0E0DC"/>
+                      </a:solidFill>
+                      <a:prstDash val="solid"/>
+                      <a:round/>
+                      <a:headEnd type="none" w="med" len="med"/>
+                      <a:tailEnd type="none" w="med" len="med"/>
+                    </a:lnR>
+                    <a:lnT w="6350" cap="flat" cmpd="sng" algn="ctr">
+                      <a:solidFill>
+                        <a:srgbClr val="E0E0DC"/>
+                      </a:solidFill>
+                      <a:prstDash val="solid"/>
+                      <a:round/>
+                      <a:headEnd type="none" w="med" len="med"/>
+                      <a:tailEnd type="none" w="med" len="med"/>
+                    </a:lnT>
+                    <a:lnB w="6350" cap="flat" cmpd="sng" algn="ctr">
+                      <a:solidFill>
+                        <a:srgbClr val="E0E0DC"/>
+                      </a:solidFill>
+                      <a:prstDash val="solid"/>
+                      <a:round/>
+                      <a:headEnd type="none" w="med" len="med"/>
+                      <a:tailEnd type="none" w="med" len="med"/>
+                    </a:lnB>
+                    <a:solidFill>
+                      <a:srgbClr val="111111"/>
+                    </a:solidFill>
+                  </a:tcPr>
+                </a:tc>
+                <a:tc>
+                  <a:txBody>
+                    <a:bodyPr/>
+                    <a:lstStyle/>
+                    <a:p>
+                      <a:pPr marL="0" indent="0" algn="l">
+                        <a:buNone/>
+                      </a:pPr>
+                      <a:r>
+                        <a:rPr lang="en-US" sz="950" b="1" dirty="0">
+                          <a:solidFill>
+                            <a:srgbClr val="FFFFFF"/>
+                          </a:solidFill>
+                          <a:latin typeface="Calibri" pitchFamily="34" charset="0"/>
+                          <a:ea typeface="Calibri" pitchFamily="34" charset="-122"/>
+                          <a:cs typeface="Calibri" pitchFamily="34" charset="-120"/>
+                        </a:rPr>
+                        <a:t>Zawiera</a:t>
+                      </a:r>
+                      <a:endParaRPr lang="en-US" sz="950" dirty="0">
+                        <a:latin typeface="Calibri" charset="0"/>
+                        <a:ea typeface="Calibri" charset="0"/>
+                        <a:cs typeface="Calibri" charset="0"/>
+                      </a:endParaRPr>
+                    </a:p>
+                  </a:txBody>
+                  <a:tcPr marL="64008" marR="64008" marT="27432" marB="27432" anchor="ctr">
+                    <a:lnL w="6350" cap="flat" cmpd="sng" algn="ctr">
+                      <a:solidFill>
+                        <a:srgbClr val="E0E0DC"/>
+                      </a:solidFill>
+                      <a:prstDash val="solid"/>
+                      <a:round/>
+                      <a:headEnd type="none" w="med" len="med"/>
+                      <a:tailEnd type="none" w="med" len="med"/>
+                    </a:lnL>
+                    <a:lnR w="6350" cap="flat" cmpd="sng" algn="ctr">
+                      <a:solidFill>
+                        <a:srgbClr val="E0E0DC"/>
+                      </a:solidFill>
+                      <a:prstDash val="solid"/>
+                      <a:round/>
+                      <a:headEnd type="none" w="med" len="med"/>
+                      <a:tailEnd type="none" w="med" len="med"/>
+                    </a:lnR>
+                    <a:lnT w="6350" cap="flat" cmpd="sng" algn="ctr">
+                      <a:solidFill>
+                        <a:srgbClr val="E0E0DC"/>
+                      </a:solidFill>
+                      <a:prstDash val="solid"/>
+                      <a:round/>
+                      <a:headEnd type="none" w="med" len="med"/>
+                      <a:tailEnd type="none" w="med" len="med"/>
+                    </a:lnT>
+                    <a:lnB w="6350" cap="flat" cmpd="sng" algn="ctr">
+                      <a:solidFill>
+                        <a:srgbClr val="E0E0DC"/>
+                      </a:solidFill>
+                      <a:prstDash val="solid"/>
+                      <a:round/>
+                      <a:headEnd type="none" w="med" len="med"/>
+                      <a:tailEnd type="none" w="med" len="med"/>
+                    </a:lnB>
+                    <a:solidFill>
+                      <a:srgbClr val="111111"/>
+                    </a:solidFill>
+                  </a:tcPr>
+                </a:tc>
+              </a:tr>
+              <a:tr h="228600">
+                <a:tc>
+                  <a:txBody>
+                    <a:bodyPr/>
+                    <a:lstStyle/>
+                    <a:p>
+                      <a:pPr marL="0" indent="0" algn="l">
+                        <a:buNone/>
+                      </a:pPr>
+                      <a:r>
+                        <a:rPr lang="en-US" sz="900" b="1" dirty="0">
+                          <a:solidFill>
+                            <a:srgbClr val="111111"/>
+                          </a:solidFill>
+                          <a:latin typeface="Calibri" pitchFamily="34" charset="0"/>
+                          <a:ea typeface="Calibri" pitchFamily="34" charset="-122"/>
+                          <a:cs typeface="Calibri" pitchFamily="34" charset="-120"/>
+                        </a:rPr>
+                        <a:t>Budowa budki + meble do aranżacji</a:t>
+                      </a:r>
+                      <a:endParaRPr lang="en-US" sz="900" dirty="0">
+                        <a:latin typeface="Calibri" charset="0"/>
+                        <a:ea typeface="Calibri" charset="0"/>
+                        <a:cs typeface="Calibri" charset="0"/>
+                      </a:endParaRPr>
+                    </a:p>
+                  </a:txBody>
+                  <a:tcPr marL="64008" marR="64008" marT="27432" marB="27432" anchor="ctr">
+                    <a:lnL w="6350" cap="flat" cmpd="sng" algn="ctr">
+                      <a:solidFill>
+                        <a:srgbClr val="E0E0DC"/>
+                      </a:solidFill>
+                      <a:prstDash val="solid"/>
+                      <a:round/>
+                      <a:headEnd type="none" w="med" len="med"/>
+                      <a:tailEnd type="none" w="med" len="med"/>
+                    </a:lnL>
+                    <a:lnR w="6350" cap="flat" cmpd="sng" algn="ctr">
+                      <a:solidFill>
+                        <a:srgbClr val="E0E0DC"/>
+                      </a:solidFill>
+                      <a:prstDash val="solid"/>
+                      <a:round/>
+                      <a:headEnd type="none" w="med" len="med"/>
+                      <a:tailEnd type="none" w="med" len="med"/>
+                    </a:lnR>
+                    <a:lnT w="6350" cap="flat" cmpd="sng" algn="ctr">
+                      <a:solidFill>
+                        <a:srgbClr val="E0E0DC"/>
+                      </a:solidFill>
+                      <a:prstDash val="solid"/>
+                      <a:round/>
+                      <a:headEnd type="none" w="med" len="med"/>
+                      <a:tailEnd type="none" w="med" len="med"/>
+                    </a:lnT>
+                    <a:lnB w="6350" cap="flat" cmpd="sng" algn="ctr">
+                      <a:solidFill>
+                        <a:srgbClr val="E0E0DC"/>
+                      </a:solidFill>
+                      <a:prstDash val="solid"/>
+                      <a:round/>
+                      <a:headEnd type="none" w="med" len="med"/>
+                      <a:tailEnd type="none" w="med" len="med"/>
+                    </a:lnB>
+                    <a:solidFill>
+                      <a:srgbClr val="FFFFFF"/>
+                    </a:solidFill>
+                  </a:tcPr>
+                </a:tc>
+                <a:tc>
+                  <a:txBody>
+                    <a:bodyPr/>
+                    <a:lstStyle/>
+                    <a:p>
+                      <a:pPr marL="0" indent="0" algn="ctr">
+                        <a:buNone/>
+                      </a:pPr>
+                      <a:r>
+                        <a:rPr lang="en-US" sz="900" b="1" dirty="0">
+                          <a:solidFill>
+                            <a:srgbClr val="4D4D4D"/>
+                          </a:solidFill>
+                          <a:latin typeface="Calibri" pitchFamily="34" charset="0"/>
+                          <a:ea typeface="Calibri" pitchFamily="34" charset="-122"/>
+                          <a:cs typeface="Calibri" pitchFamily="34" charset="-120"/>
+                        </a:rPr>
+                        <a:t>9 000–12 000 zł</a:t>
+                      </a:r>
+                      <a:endParaRPr lang="en-US" sz="900" dirty="0">
+                        <a:latin typeface="Calibri" charset="0"/>
+                        <a:ea typeface="Calibri" charset="0"/>
+                        <a:cs typeface="Calibri" charset="0"/>
+                      </a:endParaRPr>
+                    </a:p>
+                  </a:txBody>
+                  <a:tcPr marL="64008" marR="64008" marT="27432" marB="27432" anchor="ctr">
+                    <a:lnL w="6350" cap="flat" cmpd="sng" algn="ctr">
+                      <a:solidFill>
+                        <a:srgbClr val="E0E0DC"/>
+                      </a:solidFill>
+                      <a:prstDash val="solid"/>
+                      <a:round/>
+                      <a:headEnd type="none" w="med" len="med"/>
+                      <a:tailEnd type="none" w="med" len="med"/>
+                    </a:lnL>
+                    <a:lnR w="6350" cap="flat" cmpd="sng" algn="ctr">
+                      <a:solidFill>
+                        <a:srgbClr val="E0E0DC"/>
+                      </a:solidFill>
+                      <a:prstDash val="solid"/>
+                      <a:round/>
+                      <a:headEnd type="none" w="med" len="med"/>
+                      <a:tailEnd type="none" w="med" len="med"/>
+                    </a:lnR>
+                    <a:lnT w="6350" cap="flat" cmpd="sng" algn="ctr">
+                      <a:solidFill>
+                        <a:srgbClr val="E0E0DC"/>
+                      </a:solidFill>
+                      <a:prstDash val="solid"/>
+                      <a:round/>
+                      <a:headEnd type="none" w="med" len="med"/>
+                      <a:tailEnd type="none" w="med" len="med"/>
+                    </a:lnT>
+                    <a:lnB w="6350" cap="flat" cmpd="sng" algn="ctr">
+                      <a:solidFill>
+                        <a:srgbClr val="E0E0DC"/>
+                      </a:solidFill>
+                      <a:prstDash val="solid"/>
+                      <a:round/>
+                      <a:headEnd type="none" w="med" len="med"/>
+                      <a:tailEnd type="none" w="med" len="med"/>
+                    </a:lnB>
+                    <a:solidFill>
+                      <a:srgbClr val="FFFFFF"/>
+                    </a:solidFill>
+                  </a:tcPr>
+                </a:tc>
+                <a:tc>
+                  <a:txBody>
+                    <a:bodyPr/>
+                    <a:lstStyle/>
+                    <a:p>
+                      <a:pPr marL="0" indent="0" algn="l">
+                        <a:buNone/>
+                      </a:pPr>
+                      <a:r>
+                        <a:rPr lang="en-US" sz="900" dirty="0">
+                          <a:solidFill>
+                            <a:srgbClr val="4D4D4D"/>
+                          </a:solidFill>
+                          <a:latin typeface="Calibri" pitchFamily="34" charset="0"/>
+                          <a:ea typeface="Calibri" pitchFamily="34" charset="-122"/>
+                          <a:cs typeface="Calibri" pitchFamily="34" charset="-120"/>
+                        </a:rPr>
+                        <a:t>konstrukcja budki + aranżacja wnętrza (fotel, regał, stolik, lampka)</a:t>
+                      </a:r>
+                      <a:endParaRPr lang="en-US" sz="900" dirty="0">
+                        <a:latin typeface="Calibri" charset="0"/>
+                        <a:ea typeface="Calibri" charset="0"/>
+                        <a:cs typeface="Calibri" charset="0"/>
+                      </a:endParaRPr>
+                    </a:p>
+                  </a:txBody>
+                  <a:tcPr marL="64008" marR="64008" marT="27432" marB="27432" anchor="ctr">
+                    <a:lnL w="6350" cap="flat" cmpd="sng" algn="ctr">
+                      <a:solidFill>
+                        <a:srgbClr val="E0E0DC"/>
+                      </a:solidFill>
+                      <a:prstDash val="solid"/>
+                      <a:round/>
+                      <a:headEnd type="none" w="med" len="med"/>
+                      <a:tailEnd type="none" w="med" len="med"/>
+                    </a:lnL>
+                    <a:lnR w="6350" cap="flat" cmpd="sng" algn="ctr">
+                      <a:solidFill>
+                        <a:srgbClr val="E0E0DC"/>
+                      </a:solidFill>
+                      <a:prstDash val="solid"/>
+                      <a:round/>
+                      <a:headEnd type="none" w="med" len="med"/>
+                      <a:tailEnd type="none" w="med" len="med"/>
+                    </a:lnR>
+                    <a:lnT w="6350" cap="flat" cmpd="sng" algn="ctr">
+                      <a:solidFill>
+                        <a:srgbClr val="E0E0DC"/>
+                      </a:solidFill>
+                      <a:prstDash val="solid"/>
+                      <a:round/>
+                      <a:headEnd type="none" w="med" len="med"/>
+                      <a:tailEnd type="none" w="med" len="med"/>
+                    </a:lnT>
+                    <a:lnB w="6350" cap="flat" cmpd="sng" algn="ctr">
+                      <a:solidFill>
+                        <a:srgbClr val="E0E0DC"/>
+                      </a:solidFill>
+                      <a:prstDash val="solid"/>
+                      <a:round/>
+                      <a:headEnd type="none" w="med" len="med"/>
+                      <a:tailEnd type="none" w="med" len="med"/>
+                    </a:lnB>
+                    <a:solidFill>
+                      <a:srgbClr val="FFFFFF"/>
+                    </a:solidFill>
+                  </a:tcPr>
+                </a:tc>
+              </a:tr>
+              <a:tr h="228600">
+                <a:tc>
+                  <a:txBody>
+                    <a:bodyPr/>
+                    <a:lstStyle/>
+                    <a:p>
+                      <a:pPr marL="0" indent="0" algn="l">
+                        <a:buNone/>
+                      </a:pPr>
+                      <a:r>
+                        <a:rPr lang="en-US" sz="900" b="1" dirty="0">
+                          <a:solidFill>
+                            <a:srgbClr val="111111"/>
+                          </a:solidFill>
+                          <a:latin typeface="Calibri" pitchFamily="34" charset="0"/>
+                          <a:ea typeface="Calibri" pitchFamily="34" charset="-122"/>
+                          <a:cs typeface="Calibri" pitchFamily="34" charset="-120"/>
+                        </a:rPr>
+                        <a:t>Media – kampania digital</a:t>
+                      </a:r>
+                      <a:endParaRPr lang="en-US" sz="900" dirty="0">
+                        <a:latin typeface="Calibri" charset="0"/>
+                        <a:ea typeface="Calibri" charset="0"/>
+                        <a:cs typeface="Calibri" charset="0"/>
+                      </a:endParaRPr>
+                    </a:p>
+                  </a:txBody>
+                  <a:tcPr marL="64008" marR="64008" marT="27432" marB="27432" anchor="ctr">
+                    <a:lnL w="6350" cap="flat" cmpd="sng" algn="ctr">
+                      <a:solidFill>
+                        <a:srgbClr val="E0E0DC"/>
+                      </a:solidFill>
+                      <a:prstDash val="solid"/>
+                      <a:round/>
+                      <a:headEnd type="none" w="med" len="med"/>
+                      <a:tailEnd type="none" w="med" len="med"/>
+                    </a:lnL>
+                    <a:lnR w="6350" cap="flat" cmpd="sng" algn="ctr">
+                      <a:solidFill>
+                        <a:srgbClr val="E0E0DC"/>
+                      </a:solidFill>
+                      <a:prstDash val="solid"/>
+                      <a:round/>
+                      <a:headEnd type="none" w="med" len="med"/>
+                      <a:tailEnd type="none" w="med" len="med"/>
+                    </a:lnR>
+                    <a:lnT w="6350" cap="flat" cmpd="sng" algn="ctr">
+                      <a:solidFill>
+                        <a:srgbClr val="E0E0DC"/>
+                      </a:solidFill>
+                      <a:prstDash val="solid"/>
+                      <a:round/>
+                      <a:headEnd type="none" w="med" len="med"/>
+                      <a:tailEnd type="none" w="med" len="med"/>
+                    </a:lnT>
+                    <a:lnB w="6350" cap="flat" cmpd="sng" algn="ctr">
+                      <a:solidFill>
+                        <a:srgbClr val="E0E0DC"/>
+                      </a:solidFill>
+                      <a:prstDash val="solid"/>
+                      <a:round/>
+                      <a:headEnd type="none" w="med" len="med"/>
+                      <a:tailEnd type="none" w="med" len="med"/>
+                    </a:lnB>
+                    <a:solidFill>
+                      <a:srgbClr val="FFFFFF"/>
+                    </a:solidFill>
+                  </a:tcPr>
+                </a:tc>
+                <a:tc>
+                  <a:txBody>
+                    <a:bodyPr/>
+                    <a:lstStyle/>
+                    <a:p>
+                      <a:pPr marL="0" indent="0" algn="ctr">
+                        <a:buNone/>
+                      </a:pPr>
+                      <a:r>
+                        <a:rPr lang="en-US" sz="900" b="1" dirty="0">
+                          <a:solidFill>
+                            <a:srgbClr val="4D4D4D"/>
+                          </a:solidFill>
+                          <a:latin typeface="Calibri" pitchFamily="34" charset="0"/>
+                          <a:ea typeface="Calibri" pitchFamily="34" charset="-122"/>
+                          <a:cs typeface="Calibri" pitchFamily="34" charset="-120"/>
+                        </a:rPr>
+                        <a:t>300 000 zł</a:t>
+                      </a:r>
+                      <a:endParaRPr lang="en-US" sz="900" dirty="0">
+                        <a:latin typeface="Calibri" charset="0"/>
+                        <a:ea typeface="Calibri" charset="0"/>
+                        <a:cs typeface="Calibri" charset="0"/>
+                      </a:endParaRPr>
+                    </a:p>
+                  </a:txBody>
+                  <a:tcPr marL="64008" marR="64008" marT="27432" marB="27432" anchor="ctr">
+                    <a:lnL w="6350" cap="flat" cmpd="sng" algn="ctr">
+                      <a:solidFill>
+                        <a:srgbClr val="E0E0DC"/>
+                      </a:solidFill>
+                      <a:prstDash val="solid"/>
+                      <a:round/>
+                      <a:headEnd type="none" w="med" len="med"/>
+                      <a:tailEnd type="none" w="med" len="med"/>
+                    </a:lnL>
+                    <a:lnR w="6350" cap="flat" cmpd="sng" algn="ctr">
+                      <a:solidFill>
+                        <a:srgbClr val="E0E0DC"/>
+                      </a:solidFill>
+                      <a:prstDash val="solid"/>
+                      <a:round/>
+                      <a:headEnd type="none" w="med" len="med"/>
+                      <a:tailEnd type="none" w="med" len="med"/>
+                    </a:lnR>
+                    <a:lnT w="6350" cap="flat" cmpd="sng" algn="ctr">
+                      <a:solidFill>
+                        <a:srgbClr val="E0E0DC"/>
+                      </a:solidFill>
+                      <a:prstDash val="solid"/>
+                      <a:round/>
+                      <a:headEnd type="none" w="med" len="med"/>
+                      <a:tailEnd type="none" w="med" len="med"/>
+                    </a:lnT>
+                    <a:lnB w="6350" cap="flat" cmpd="sng" algn="ctr">
+                      <a:solidFill>
+                        <a:srgbClr val="E0E0DC"/>
+                      </a:solidFill>
+                      <a:prstDash val="solid"/>
+                      <a:round/>
+                      <a:headEnd type="none" w="med" len="med"/>
+                      <a:tailEnd type="none" w="med" len="med"/>
+                    </a:lnB>
+                    <a:solidFill>
+                      <a:srgbClr val="FFFFFF"/>
+                    </a:solidFill>
+                  </a:tcPr>
+                </a:tc>
+                <a:tc>
+                  <a:txBody>
+                    <a:bodyPr/>
+                    <a:lstStyle/>
+                    <a:p>
+                      <a:pPr marL="0" indent="0" algn="l">
+                        <a:buNone/>
+                      </a:pPr>
+                      <a:r>
+                        <a:rPr lang="en-US" sz="900" dirty="0">
+                          <a:solidFill>
+                            <a:srgbClr val="4D4D4D"/>
+                          </a:solidFill>
+                          <a:latin typeface="Calibri" pitchFamily="34" charset="0"/>
+                          <a:ea typeface="Calibri" pitchFamily="34" charset="-122"/>
+                          <a:cs typeface="Calibri" pitchFamily="34" charset="-120"/>
+                        </a:rPr>
+                        <a:t>Meta, TikTok, YouTube, GDN, Google Search – podział jak w prezentacji</a:t>
+                      </a:r>
+                      <a:endParaRPr lang="en-US" sz="900" dirty="0">
+                        <a:latin typeface="Calibri" charset="0"/>
+                        <a:ea typeface="Calibri" charset="0"/>
+                        <a:cs typeface="Calibri" charset="0"/>
+                      </a:endParaRPr>
+                    </a:p>
+                  </a:txBody>
+                  <a:tcPr marL="64008" marR="64008" marT="27432" marB="27432" anchor="ctr">
+                    <a:lnL w="6350" cap="flat" cmpd="sng" algn="ctr">
+                      <a:solidFill>
+                        <a:srgbClr val="E0E0DC"/>
+                      </a:solidFill>
+                      <a:prstDash val="solid"/>
+                      <a:round/>
+                      <a:headEnd type="none" w="med" len="med"/>
+                      <a:tailEnd type="none" w="med" len="med"/>
+                    </a:lnL>
+                    <a:lnR w="6350" cap="flat" cmpd="sng" algn="ctr">
+                      <a:solidFill>
+                        <a:srgbClr val="E0E0DC"/>
+                      </a:solidFill>
+                      <a:prstDash val="solid"/>
+                      <a:round/>
+                      <a:headEnd type="none" w="med" len="med"/>
+                      <a:tailEnd type="none" w="med" len="med"/>
+                    </a:lnR>
+                    <a:lnT w="6350" cap="flat" cmpd="sng" algn="ctr">
+                      <a:solidFill>
+                        <a:srgbClr val="E0E0DC"/>
+                      </a:solidFill>
+                      <a:prstDash val="solid"/>
+                      <a:round/>
+                      <a:headEnd type="none" w="med" len="med"/>
+                      <a:tailEnd type="none" w="med" len="med"/>
+                    </a:lnT>
+                    <a:lnB w="6350" cap="flat" cmpd="sng" algn="ctr">
+                      <a:solidFill>
+                        <a:srgbClr val="E0E0DC"/>
+                      </a:solidFill>
+                      <a:prstDash val="solid"/>
+                      <a:round/>
+                      <a:headEnd type="none" w="med" len="med"/>
+                      <a:tailEnd type="none" w="med" len="med"/>
+                    </a:lnB>
+                    <a:solidFill>
+                      <a:srgbClr val="FFFFFF"/>
+                    </a:solidFill>
+                  </a:tcPr>
+                </a:tc>
+              </a:tr>
+              <a:tr h="228600">
+                <a:tc>
+                  <a:txBody>
+                    <a:bodyPr/>
+                    <a:lstStyle/>
+                    <a:p>
+                      <a:pPr marL="0" indent="0" algn="l">
+                        <a:buNone/>
+                      </a:pPr>
+                      <a:r>
+                        <a:rPr lang="en-US" sz="900" b="1" dirty="0">
+                          <a:solidFill>
+                            <a:srgbClr val="111111"/>
+                          </a:solidFill>
+                          <a:latin typeface="Calibri" pitchFamily="34" charset="0"/>
+                          <a:ea typeface="Calibri" pitchFamily="34" charset="-122"/>
+                          <a:cs typeface="Calibri" pitchFamily="34" charset="-120"/>
+                        </a:rPr>
+                        <a:t>Media – influencerzy</a:t>
+                      </a:r>
+                      <a:endParaRPr lang="en-US" sz="900" dirty="0">
+                        <a:latin typeface="Calibri" charset="0"/>
+                        <a:ea typeface="Calibri" charset="0"/>
+                        <a:cs typeface="Calibri" charset="0"/>
+                      </a:endParaRPr>
+                    </a:p>
+                  </a:txBody>
+                  <a:tcPr marL="64008" marR="64008" marT="27432" marB="27432" anchor="ctr">
+                    <a:lnL w="6350" cap="flat" cmpd="sng" algn="ctr">
+                      <a:solidFill>
+                        <a:srgbClr val="E0E0DC"/>
+                      </a:solidFill>
+                      <a:prstDash val="solid"/>
+                      <a:round/>
+                      <a:headEnd type="none" w="med" len="med"/>
+                      <a:tailEnd type="none" w="med" len="med"/>
+                    </a:lnL>
+                    <a:lnR w="6350" cap="flat" cmpd="sng" algn="ctr">
+                      <a:solidFill>
+                        <a:srgbClr val="E0E0DC"/>
+                      </a:solidFill>
+                      <a:prstDash val="solid"/>
+                      <a:round/>
+                      <a:headEnd type="none" w="med" len="med"/>
+                      <a:tailEnd type="none" w="med" len="med"/>
+                    </a:lnR>
+                    <a:lnT w="6350" cap="flat" cmpd="sng" algn="ctr">
+                      <a:solidFill>
+                        <a:srgbClr val="E0E0DC"/>
+                      </a:solidFill>
+                      <a:prstDash val="solid"/>
+                      <a:round/>
+                      <a:headEnd type="none" w="med" len="med"/>
+                      <a:tailEnd type="none" w="med" len="med"/>
+                    </a:lnT>
+                    <a:lnB w="6350" cap="flat" cmpd="sng" algn="ctr">
+                      <a:solidFill>
+                        <a:srgbClr val="E0E0DC"/>
+                      </a:solidFill>
+                      <a:prstDash val="solid"/>
+                      <a:round/>
+                      <a:headEnd type="none" w="med" len="med"/>
+                      <a:tailEnd type="none" w="med" len="med"/>
+                    </a:lnB>
+                    <a:solidFill>
+                      <a:srgbClr val="FFFFFF"/>
+                    </a:solidFill>
+                  </a:tcPr>
+                </a:tc>
+                <a:tc>
+                  <a:txBody>
+                    <a:bodyPr/>
+                    <a:lstStyle/>
+                    <a:p>
+                      <a:pPr marL="0" indent="0" algn="ctr">
+                        <a:buNone/>
+                      </a:pPr>
+                      <a:r>
+                        <a:rPr lang="en-US" sz="900" b="1" dirty="0">
+                          <a:solidFill>
+                            <a:srgbClr val="4D4D4D"/>
+                          </a:solidFill>
+                          <a:latin typeface="Calibri" pitchFamily="34" charset="0"/>
+                          <a:ea typeface="Calibri" pitchFamily="34" charset="-122"/>
+                          <a:cs typeface="Calibri" pitchFamily="34" charset="-120"/>
+                        </a:rPr>
+                        <a:t>150 000 zł</a:t>
+                      </a:r>
+                      <a:endParaRPr lang="en-US" sz="900" dirty="0">
+                        <a:latin typeface="Calibri" charset="0"/>
+                        <a:ea typeface="Calibri" charset="0"/>
+                        <a:cs typeface="Calibri" charset="0"/>
+                      </a:endParaRPr>
+                    </a:p>
+                  </a:txBody>
+                  <a:tcPr marL="64008" marR="64008" marT="27432" marB="27432" anchor="ctr">
+                    <a:lnL w="6350" cap="flat" cmpd="sng" algn="ctr">
+                      <a:solidFill>
+                        <a:srgbClr val="E0E0DC"/>
+                      </a:solidFill>
+                      <a:prstDash val="solid"/>
+                      <a:round/>
+                      <a:headEnd type="none" w="med" len="med"/>
+                      <a:tailEnd type="none" w="med" len="med"/>
+                    </a:lnL>
+                    <a:lnR w="6350" cap="flat" cmpd="sng" algn="ctr">
+                      <a:solidFill>
+                        <a:srgbClr val="E0E0DC"/>
+                      </a:solidFill>
+                      <a:prstDash val="solid"/>
+                      <a:round/>
+                      <a:headEnd type="none" w="med" len="med"/>
+                      <a:tailEnd type="none" w="med" len="med"/>
+                    </a:lnR>
+                    <a:lnT w="6350" cap="flat" cmpd="sng" algn="ctr">
+                      <a:solidFill>
+                        <a:srgbClr val="E0E0DC"/>
+                      </a:solidFill>
+                      <a:prstDash val="solid"/>
+                      <a:round/>
+                      <a:headEnd type="none" w="med" len="med"/>
+                      <a:tailEnd type="none" w="med" len="med"/>
+                    </a:lnT>
+                    <a:lnB w="6350" cap="flat" cmpd="sng" algn="ctr">
+                      <a:solidFill>
+                        <a:srgbClr val="E0E0DC"/>
+                      </a:solidFill>
+                      <a:prstDash val="solid"/>
+                      <a:round/>
+                      <a:headEnd type="none" w="med" len="med"/>
+                      <a:tailEnd type="none" w="med" len="med"/>
+                    </a:lnB>
+                    <a:solidFill>
+                      <a:srgbClr val="FFFFFF"/>
+                    </a:solidFill>
+                  </a:tcPr>
+                </a:tc>
+                <a:tc>
+                  <a:txBody>
+                    <a:bodyPr/>
+                    <a:lstStyle/>
+                    <a:p>
+                      <a:pPr marL="0" indent="0" algn="l">
+                        <a:buNone/>
+                      </a:pPr>
+                      <a:r>
+                        <a:rPr lang="en-US" sz="900" dirty="0">
+                          <a:solidFill>
+                            <a:srgbClr val="4D4D4D"/>
+                          </a:solidFill>
+                          <a:latin typeface="Calibri" pitchFamily="34" charset="0"/>
+                          <a:ea typeface="Calibri" pitchFamily="34" charset="-122"/>
+                          <a:cs typeface="Calibri" pitchFamily="34" charset="-120"/>
+                        </a:rPr>
+                        <a:t>4–6 twórców 250 tys.+, publikacje z płatną amplifikacją</a:t>
+                      </a:r>
+                      <a:endParaRPr lang="en-US" sz="900" dirty="0">
+                        <a:latin typeface="Calibri" charset="0"/>
+                        <a:ea typeface="Calibri" charset="0"/>
+                        <a:cs typeface="Calibri" charset="0"/>
+                      </a:endParaRPr>
+                    </a:p>
+                  </a:txBody>
+                  <a:tcPr marL="64008" marR="64008" marT="27432" marB="27432" anchor="ctr">
+                    <a:lnL w="6350" cap="flat" cmpd="sng" algn="ctr">
+                      <a:solidFill>
+                        <a:srgbClr val="E0E0DC"/>
+                      </a:solidFill>
+                      <a:prstDash val="solid"/>
+                      <a:round/>
+                      <a:headEnd type="none" w="med" len="med"/>
+                      <a:tailEnd type="none" w="med" len="med"/>
+                    </a:lnL>
+                    <a:lnR w="6350" cap="flat" cmpd="sng" algn="ctr">
+                      <a:solidFill>
+                        <a:srgbClr val="E0E0DC"/>
+                      </a:solidFill>
+                      <a:prstDash val="solid"/>
+                      <a:round/>
+                      <a:headEnd type="none" w="med" len="med"/>
+                      <a:tailEnd type="none" w="med" len="med"/>
+                    </a:lnR>
+                    <a:lnT w="6350" cap="flat" cmpd="sng" algn="ctr">
+                      <a:solidFill>
+                        <a:srgbClr val="E0E0DC"/>
+                      </a:solidFill>
+                      <a:prstDash val="solid"/>
+                      <a:round/>
+                      <a:headEnd type="none" w="med" len="med"/>
+                      <a:tailEnd type="none" w="med" len="med"/>
+                    </a:lnT>
+                    <a:lnB w="6350" cap="flat" cmpd="sng" algn="ctr">
+                      <a:solidFill>
+                        <a:srgbClr val="E0E0DC"/>
+                      </a:solidFill>
+                      <a:prstDash val="solid"/>
+                      <a:round/>
+                      <a:headEnd type="none" w="med" len="med"/>
+                      <a:tailEnd type="none" w="med" len="med"/>
+                    </a:lnB>
+                    <a:solidFill>
+                      <a:srgbClr val="FFFFFF"/>
+                    </a:solidFill>
+                  </a:tcPr>
+                </a:tc>
+              </a:tr>
+              <a:tr h="228600">
+                <a:tc>
+                  <a:txBody>
+                    <a:bodyPr/>
+                    <a:lstStyle/>
+                    <a:p>
+                      <a:pPr marL="0" indent="0" algn="l">
+                        <a:buNone/>
+                      </a:pPr>
+                      <a:r>
+                        <a:rPr lang="en-US" sz="900" b="1" dirty="0">
+                          <a:solidFill>
+                            <a:srgbClr val="111111"/>
+                          </a:solidFill>
+                          <a:latin typeface="Calibri" pitchFamily="34" charset="0"/>
+                          <a:ea typeface="Calibri" pitchFamily="34" charset="-122"/>
+                          <a:cs typeface="Calibri" pitchFamily="34" charset="-120"/>
+                        </a:rPr>
+                        <a:t>Media – działania PR</a:t>
+                      </a:r>
+                      <a:endParaRPr lang="en-US" sz="900" dirty="0">
+                        <a:latin typeface="Calibri" charset="0"/>
+                        <a:ea typeface="Calibri" charset="0"/>
+                        <a:cs typeface="Calibri" charset="0"/>
+                      </a:endParaRPr>
+                    </a:p>
+                  </a:txBody>
+                  <a:tcPr marL="64008" marR="64008" marT="27432" marB="27432" anchor="ctr">
+                    <a:lnL w="6350" cap="flat" cmpd="sng" algn="ctr">
+                      <a:solidFill>
+                        <a:srgbClr val="E0E0DC"/>
+                      </a:solidFill>
+                      <a:prstDash val="solid"/>
+                      <a:round/>
+                      <a:headEnd type="none" w="med" len="med"/>
+                      <a:tailEnd type="none" w="med" len="med"/>
+                    </a:lnL>
+                    <a:lnR w="6350" cap="flat" cmpd="sng" algn="ctr">
+                      <a:solidFill>
+                        <a:srgbClr val="E0E0DC"/>
+                      </a:solidFill>
+                      <a:prstDash val="solid"/>
+                      <a:round/>
+                      <a:headEnd type="none" w="med" len="med"/>
+                      <a:tailEnd type="none" w="med" len="med"/>
+                    </a:lnR>
+                    <a:lnT w="6350" cap="flat" cmpd="sng" algn="ctr">
+                      <a:solidFill>
+                        <a:srgbClr val="E0E0DC"/>
+                      </a:solidFill>
+                      <a:prstDash val="solid"/>
+                      <a:round/>
+                      <a:headEnd type="none" w="med" len="med"/>
+                      <a:tailEnd type="none" w="med" len="med"/>
+                    </a:lnT>
+                    <a:lnB w="6350" cap="flat" cmpd="sng" algn="ctr">
+                      <a:solidFill>
+                        <a:srgbClr val="E0E0DC"/>
+                      </a:solidFill>
+                      <a:prstDash val="solid"/>
+                      <a:round/>
+                      <a:headEnd type="none" w="med" len="med"/>
+                      <a:tailEnd type="none" w="med" len="med"/>
+                    </a:lnB>
+                    <a:solidFill>
+                      <a:srgbClr val="FFFFFF"/>
+                    </a:solidFill>
+                  </a:tcPr>
+                </a:tc>
+                <a:tc>
+                  <a:txBody>
+                    <a:bodyPr/>
+                    <a:lstStyle/>
+                    <a:p>
+                      <a:pPr marL="0" indent="0" algn="ctr">
+                        <a:buNone/>
+                      </a:pPr>
+                      <a:r>
+                        <a:rPr lang="en-US" sz="900" b="1" dirty="0">
+                          <a:solidFill>
+                            <a:srgbClr val="4D4D4D"/>
+                          </a:solidFill>
+                          <a:latin typeface="Calibri" pitchFamily="34" charset="0"/>
+                          <a:ea typeface="Calibri" pitchFamily="34" charset="-122"/>
+                          <a:cs typeface="Calibri" pitchFamily="34" charset="-120"/>
+                        </a:rPr>
+                        <a:t>50 000 zł</a:t>
+                      </a:r>
+                      <a:endParaRPr lang="en-US" sz="900" dirty="0">
+                        <a:latin typeface="Calibri" charset="0"/>
+                        <a:ea typeface="Calibri" charset="0"/>
+                        <a:cs typeface="Calibri" charset="0"/>
+                      </a:endParaRPr>
+                    </a:p>
+                  </a:txBody>
+                  <a:tcPr marL="64008" marR="64008" marT="27432" marB="27432" anchor="ctr">
+                    <a:lnL w="6350" cap="flat" cmpd="sng" algn="ctr">
+                      <a:solidFill>
+                        <a:srgbClr val="E0E0DC"/>
+                      </a:solidFill>
+                      <a:prstDash val="solid"/>
+                      <a:round/>
+                      <a:headEnd type="none" w="med" len="med"/>
+                      <a:tailEnd type="none" w="med" len="med"/>
+                    </a:lnL>
+                    <a:lnR w="6350" cap="flat" cmpd="sng" algn="ctr">
+                      <a:solidFill>
+                        <a:srgbClr val="E0E0DC"/>
+                      </a:solidFill>
+                      <a:prstDash val="solid"/>
+                      <a:round/>
+                      <a:headEnd type="none" w="med" len="med"/>
+                      <a:tailEnd type="none" w="med" len="med"/>
+                    </a:lnR>
+                    <a:lnT w="6350" cap="flat" cmpd="sng" algn="ctr">
+                      <a:solidFill>
+                        <a:srgbClr val="E0E0DC"/>
+                      </a:solidFill>
+                      <a:prstDash val="solid"/>
+                      <a:round/>
+                      <a:headEnd type="none" w="med" len="med"/>
+                      <a:tailEnd type="none" w="med" len="med"/>
+                    </a:lnT>
+                    <a:lnB w="6350" cap="flat" cmpd="sng" algn="ctr">
+                      <a:solidFill>
+                        <a:srgbClr val="E0E0DC"/>
+                      </a:solidFill>
+                      <a:prstDash val="solid"/>
+                      <a:round/>
+                      <a:headEnd type="none" w="med" len="med"/>
+                      <a:tailEnd type="none" w="med" len="med"/>
+                    </a:lnB>
+                    <a:solidFill>
+                      <a:srgbClr val="FFFFFF"/>
+                    </a:solidFill>
+                  </a:tcPr>
+                </a:tc>
+                <a:tc>
+                  <a:txBody>
+                    <a:bodyPr/>
+                    <a:lstStyle/>
+                    <a:p>
+                      <a:pPr marL="0" indent="0" algn="l">
+                        <a:buNone/>
+                      </a:pPr>
+                      <a:r>
+                        <a:rPr lang="en-US" sz="900" dirty="0">
+                          <a:solidFill>
+                            <a:srgbClr val="4D4D4D"/>
+                          </a:solidFill>
+                          <a:latin typeface="Calibri" pitchFamily="34" charset="0"/>
+                          <a:ea typeface="Calibri" pitchFamily="34" charset="-122"/>
+                          <a:cs typeface="Calibri" pitchFamily="34" charset="-120"/>
+                        </a:rPr>
+                        <a:t>6 artykułów sponsorowanych, media relations, briefing prasowy</a:t>
+                      </a:r>
+                      <a:endParaRPr lang="en-US" sz="900" dirty="0">
+                        <a:latin typeface="Calibri" charset="0"/>
+                        <a:ea typeface="Calibri" charset="0"/>
+                        <a:cs typeface="Calibri" charset="0"/>
+                      </a:endParaRPr>
+                    </a:p>
+                  </a:txBody>
+                  <a:tcPr marL="64008" marR="64008" marT="27432" marB="27432" anchor="ctr">
+                    <a:lnL w="6350" cap="flat" cmpd="sng" algn="ctr">
+                      <a:solidFill>
+                        <a:srgbClr val="E0E0DC"/>
+                      </a:solidFill>
+                      <a:prstDash val="solid"/>
+                      <a:round/>
+                      <a:headEnd type="none" w="med" len="med"/>
+                      <a:tailEnd type="none" w="med" len="med"/>
+                    </a:lnL>
+                    <a:lnR w="6350" cap="flat" cmpd="sng" algn="ctr">
+                      <a:solidFill>
+                        <a:srgbClr val="E0E0DC"/>
+                      </a:solidFill>
+                      <a:prstDash val="solid"/>
+                      <a:round/>
+                      <a:headEnd type="none" w="med" len="med"/>
+                      <a:tailEnd type="none" w="med" len="med"/>
+                    </a:lnR>
+                    <a:lnT w="6350" cap="flat" cmpd="sng" algn="ctr">
+                      <a:solidFill>
+                        <a:srgbClr val="E0E0DC"/>
+                      </a:solidFill>
+                      <a:prstDash val="solid"/>
+                      <a:round/>
+                      <a:headEnd type="none" w="med" len="med"/>
+                      <a:tailEnd type="none" w="med" len="med"/>
+                    </a:lnT>
+                    <a:lnB w="6350" cap="flat" cmpd="sng" algn="ctr">
+                      <a:solidFill>
+                        <a:srgbClr val="E0E0DC"/>
+                      </a:solidFill>
+                      <a:prstDash val="solid"/>
+                      <a:round/>
+                      <a:headEnd type="none" w="med" len="med"/>
+                      <a:tailEnd type="none" w="med" len="med"/>
+                    </a:lnB>
+                    <a:solidFill>
+                      <a:srgbClr val="FFFFFF"/>
+                    </a:solidFill>
+                  </a:tcPr>
+                </a:tc>
+              </a:tr>
+              <a:tr h="228600">
+                <a:tc>
+                  <a:txBody>
+                    <a:bodyPr/>
+                    <a:lstStyle/>
+                    <a:p>
+                      <a:pPr marL="0" indent="0" algn="l">
+                        <a:buNone/>
+                      </a:pPr>
+                      <a:r>
+                        <a:rPr lang="en-US" sz="900" b="1" dirty="0">
+                          <a:solidFill>
+                            <a:srgbClr val="111111"/>
+                          </a:solidFill>
+                          <a:latin typeface="Calibri" pitchFamily="34" charset="0"/>
+                          <a:ea typeface="Calibri" pitchFamily="34" charset="-122"/>
+                          <a:cs typeface="Calibri" pitchFamily="34" charset="-120"/>
+                        </a:rPr>
+                        <a:t>Fee mediowe – 15% budżetu digital</a:t>
+                      </a:r>
+                      <a:endParaRPr lang="en-US" sz="900" dirty="0">
+                        <a:latin typeface="Calibri" charset="0"/>
+                        <a:ea typeface="Calibri" charset="0"/>
+                        <a:cs typeface="Calibri" charset="0"/>
+                      </a:endParaRPr>
+                    </a:p>
+                  </a:txBody>
+                  <a:tcPr marL="64008" marR="64008" marT="27432" marB="27432" anchor="ctr">
+                    <a:lnL w="6350" cap="flat" cmpd="sng" algn="ctr">
+                      <a:solidFill>
+                        <a:srgbClr val="E0E0DC"/>
+                      </a:solidFill>
+                      <a:prstDash val="solid"/>
+                      <a:round/>
+                      <a:headEnd type="none" w="med" len="med"/>
+                      <a:tailEnd type="none" w="med" len="med"/>
+                    </a:lnL>
+                    <a:lnR w="6350" cap="flat" cmpd="sng" algn="ctr">
+                      <a:solidFill>
+                        <a:srgbClr val="E0E0DC"/>
+                      </a:solidFill>
+                      <a:prstDash val="solid"/>
+                      <a:round/>
+                      <a:headEnd type="none" w="med" len="med"/>
+                      <a:tailEnd type="none" w="med" len="med"/>
+                    </a:lnR>
+                    <a:lnT w="6350" cap="flat" cmpd="sng" algn="ctr">
+                      <a:solidFill>
+                        <a:srgbClr val="E0E0DC"/>
+                      </a:solidFill>
+                      <a:prstDash val="solid"/>
+                      <a:round/>
+                      <a:headEnd type="none" w="med" len="med"/>
+                      <a:tailEnd type="none" w="med" len="med"/>
+                    </a:lnT>
+                    <a:lnB w="6350" cap="flat" cmpd="sng" algn="ctr">
+                      <a:solidFill>
+                        <a:srgbClr val="E0E0DC"/>
+                      </a:solidFill>
+                      <a:prstDash val="solid"/>
+                      <a:round/>
+                      <a:headEnd type="none" w="med" len="med"/>
+                      <a:tailEnd type="none" w="med" len="med"/>
+                    </a:lnB>
+                    <a:solidFill>
+                      <a:srgbClr val="FFFFFF"/>
+                    </a:solidFill>
+                  </a:tcPr>
+                </a:tc>
+                <a:tc>
+                  <a:txBody>
+                    <a:bodyPr/>
+                    <a:lstStyle/>
+                    <a:p>
+                      <a:pPr marL="0" indent="0" algn="ctr">
+                        <a:buNone/>
+                      </a:pPr>
+                      <a:r>
+                        <a:rPr lang="en-US" sz="900" b="1" dirty="0">
+                          <a:solidFill>
+                            <a:srgbClr val="4D4D4D"/>
+                          </a:solidFill>
+                          <a:latin typeface="Calibri" pitchFamily="34" charset="0"/>
+                          <a:ea typeface="Calibri" pitchFamily="34" charset="-122"/>
+                          <a:cs typeface="Calibri" pitchFamily="34" charset="-120"/>
+                        </a:rPr>
+                        <a:t>45 000 zł</a:t>
+                      </a:r>
+                      <a:endParaRPr lang="en-US" sz="900" dirty="0">
+                        <a:latin typeface="Calibri" charset="0"/>
+                        <a:ea typeface="Calibri" charset="0"/>
+                        <a:cs typeface="Calibri" charset="0"/>
+                      </a:endParaRPr>
+                    </a:p>
+                  </a:txBody>
+                  <a:tcPr marL="64008" marR="64008" marT="27432" marB="27432" anchor="ctr">
+                    <a:lnL w="6350" cap="flat" cmpd="sng" algn="ctr">
+                      <a:solidFill>
+                        <a:srgbClr val="E0E0DC"/>
+                      </a:solidFill>
+                      <a:prstDash val="solid"/>
+                      <a:round/>
+                      <a:headEnd type="none" w="med" len="med"/>
+                      <a:tailEnd type="none" w="med" len="med"/>
+                    </a:lnL>
+                    <a:lnR w="6350" cap="flat" cmpd="sng" algn="ctr">
+                      <a:solidFill>
+                        <a:srgbClr val="E0E0DC"/>
+                      </a:solidFill>
+                      <a:prstDash val="solid"/>
+                      <a:round/>
+                      <a:headEnd type="none" w="med" len="med"/>
+                      <a:tailEnd type="none" w="med" len="med"/>
+                    </a:lnR>
+                    <a:lnT w="6350" cap="flat" cmpd="sng" algn="ctr">
+                      <a:solidFill>
+                        <a:srgbClr val="E0E0DC"/>
+                      </a:solidFill>
+                      <a:prstDash val="solid"/>
+                      <a:round/>
+                      <a:headEnd type="none" w="med" len="med"/>
+                      <a:tailEnd type="none" w="med" len="med"/>
+                    </a:lnT>
+                    <a:lnB w="6350" cap="flat" cmpd="sng" algn="ctr">
+                      <a:solidFill>
+                        <a:srgbClr val="E0E0DC"/>
+                      </a:solidFill>
+                      <a:prstDash val="solid"/>
+                      <a:round/>
+                      <a:headEnd type="none" w="med" len="med"/>
+                      <a:tailEnd type="none" w="med" len="med"/>
+                    </a:lnB>
+                    <a:solidFill>
+                      <a:srgbClr val="FFFFFF"/>
+                    </a:solidFill>
+                  </a:tcPr>
+                </a:tc>
+                <a:tc>
+                  <a:txBody>
+                    <a:bodyPr/>
+                    <a:lstStyle/>
+                    <a:p>
+                      <a:pPr marL="0" indent="0" algn="l">
+                        <a:buNone/>
+                      </a:pPr>
+                      <a:r>
+                        <a:rPr lang="en-US" sz="900" dirty="0">
+                          <a:solidFill>
+                            <a:srgbClr val="4D4D4D"/>
+                          </a:solidFill>
+                          <a:latin typeface="Calibri" pitchFamily="34" charset="0"/>
+                          <a:ea typeface="Calibri" pitchFamily="34" charset="-122"/>
+                          <a:cs typeface="Calibri" pitchFamily="34" charset="-120"/>
+                        </a:rPr>
+                        <a:t>setup, prowadzenie i optymalizacja kampanii, raportowanie</a:t>
+                      </a:r>
+                      <a:endParaRPr lang="en-US" sz="900" dirty="0">
+                        <a:latin typeface="Calibri" charset="0"/>
+                        <a:ea typeface="Calibri" charset="0"/>
+                        <a:cs typeface="Calibri" charset="0"/>
+                      </a:endParaRPr>
+                    </a:p>
+                  </a:txBody>
+                  <a:tcPr marL="64008" marR="64008" marT="27432" marB="27432" anchor="ctr">
+                    <a:lnL w="6350" cap="flat" cmpd="sng" algn="ctr">
+                      <a:solidFill>
+                        <a:srgbClr val="E0E0DC"/>
+                      </a:solidFill>
+                      <a:prstDash val="solid"/>
+                      <a:round/>
+                      <a:headEnd type="none" w="med" len="med"/>
+                      <a:tailEnd type="none" w="med" len="med"/>
+                    </a:lnL>
+                    <a:lnR w="6350" cap="flat" cmpd="sng" algn="ctr">
+                      <a:solidFill>
+                        <a:srgbClr val="E0E0DC"/>
+                      </a:solidFill>
+                      <a:prstDash val="solid"/>
+                      <a:round/>
+                      <a:headEnd type="none" w="med" len="med"/>
+                      <a:tailEnd type="none" w="med" len="med"/>
+                    </a:lnR>
+                    <a:lnT w="6350" cap="flat" cmpd="sng" algn="ctr">
+                      <a:solidFill>
+                        <a:srgbClr val="E0E0DC"/>
+                      </a:solidFill>
+                      <a:prstDash val="solid"/>
+                      <a:round/>
+                      <a:headEnd type="none" w="med" len="med"/>
+                      <a:tailEnd type="none" w="med" len="med"/>
+                    </a:lnT>
+                    <a:lnB w="6350" cap="flat" cmpd="sng" algn="ctr">
+                      <a:solidFill>
+                        <a:srgbClr val="E0E0DC"/>
+                      </a:solidFill>
+                      <a:prstDash val="solid"/>
+                      <a:round/>
+                      <a:headEnd type="none" w="med" len="med"/>
+                      <a:tailEnd type="none" w="med" len="med"/>
+                    </a:lnB>
+                    <a:solidFill>
+                      <a:srgbClr val="FFFFFF"/>
+                    </a:solidFill>
+                  </a:tcPr>
+                </a:tc>
+              </a:tr>
+              <a:tr h="228600">
+                <a:tc>
+                  <a:txBody>
+                    <a:bodyPr/>
+                    <a:lstStyle/>
+                    <a:p>
+                      <a:pPr marL="0" indent="0" algn="l">
+                        <a:buNone/>
+                      </a:pPr>
+                      <a:r>
+                        <a:rPr lang="en-US" sz="900" b="1" dirty="0">
+                          <a:solidFill>
+                            <a:srgbClr val="111111"/>
+                          </a:solidFill>
+                          <a:latin typeface="Calibri" pitchFamily="34" charset="0"/>
+                          <a:ea typeface="Calibri" pitchFamily="34" charset="-122"/>
+                          <a:cs typeface="Calibri" pitchFamily="34" charset="-120"/>
+                        </a:rPr>
+                        <a:t>Kreacja – KV + formaty do kampanii</a:t>
+                      </a:r>
+                      <a:endParaRPr lang="en-US" sz="900" dirty="0">
+                        <a:latin typeface="Calibri" charset="0"/>
+                        <a:ea typeface="Calibri" charset="0"/>
+                        <a:cs typeface="Calibri" charset="0"/>
+                      </a:endParaRPr>
+                    </a:p>
+                  </a:txBody>
+                  <a:tcPr marL="64008" marR="64008" marT="27432" marB="27432" anchor="ctr">
+                    <a:lnL w="6350" cap="flat" cmpd="sng" algn="ctr">
+                      <a:solidFill>
+                        <a:srgbClr val="E0E0DC"/>
+                      </a:solidFill>
+                      <a:prstDash val="solid"/>
+                      <a:round/>
+                      <a:headEnd type="none" w="med" len="med"/>
+                      <a:tailEnd type="none" w="med" len="med"/>
+                    </a:lnL>
+                    <a:lnR w="6350" cap="flat" cmpd="sng" algn="ctr">
+                      <a:solidFill>
+                        <a:srgbClr val="E0E0DC"/>
+                      </a:solidFill>
+                      <a:prstDash val="solid"/>
+                      <a:round/>
+                      <a:headEnd type="none" w="med" len="med"/>
+                      <a:tailEnd type="none" w="med" len="med"/>
+                    </a:lnR>
+                    <a:lnT w="6350" cap="flat" cmpd="sng" algn="ctr">
+                      <a:solidFill>
+                        <a:srgbClr val="E0E0DC"/>
+                      </a:solidFill>
+                      <a:prstDash val="solid"/>
+                      <a:round/>
+                      <a:headEnd type="none" w="med" len="med"/>
+                      <a:tailEnd type="none" w="med" len="med"/>
+                    </a:lnT>
+                    <a:lnB w="6350" cap="flat" cmpd="sng" algn="ctr">
+                      <a:solidFill>
+                        <a:srgbClr val="E0E0DC"/>
+                      </a:solidFill>
+                      <a:prstDash val="solid"/>
+                      <a:round/>
+                      <a:headEnd type="none" w="med" len="med"/>
+                      <a:tailEnd type="none" w="med" len="med"/>
+                    </a:lnB>
+                    <a:solidFill>
+                      <a:srgbClr val="FFFFFF"/>
+                    </a:solidFill>
+                  </a:tcPr>
+                </a:tc>
+                <a:tc>
+                  <a:txBody>
+                    <a:bodyPr/>
+                    <a:lstStyle/>
+                    <a:p>
+                      <a:pPr marL="0" indent="0" algn="ctr">
+                        <a:buNone/>
+                      </a:pPr>
+                      <a:r>
+                        <a:rPr lang="en-US" sz="900" b="1" dirty="0">
+                          <a:solidFill>
+                            <a:srgbClr val="4D4D4D"/>
+                          </a:solidFill>
+                          <a:latin typeface="Calibri" pitchFamily="34" charset="0"/>
+                          <a:ea typeface="Calibri" pitchFamily="34" charset="-122"/>
+                          <a:cs typeface="Calibri" pitchFamily="34" charset="-120"/>
+                        </a:rPr>
+                        <a:t>9 000 zł</a:t>
+                      </a:r>
+                      <a:endParaRPr lang="en-US" sz="900" dirty="0">
+                        <a:latin typeface="Calibri" charset="0"/>
+                        <a:ea typeface="Calibri" charset="0"/>
+                        <a:cs typeface="Calibri" charset="0"/>
+                      </a:endParaRPr>
+                    </a:p>
+                  </a:txBody>
+                  <a:tcPr marL="64008" marR="64008" marT="27432" marB="27432" anchor="ctr">
+                    <a:lnL w="6350" cap="flat" cmpd="sng" algn="ctr">
+                      <a:solidFill>
+                        <a:srgbClr val="E0E0DC"/>
+                      </a:solidFill>
+                      <a:prstDash val="solid"/>
+                      <a:round/>
+                      <a:headEnd type="none" w="med" len="med"/>
+                      <a:tailEnd type="none" w="med" len="med"/>
+                    </a:lnL>
+                    <a:lnR w="6350" cap="flat" cmpd="sng" algn="ctr">
+                      <a:solidFill>
+                        <a:srgbClr val="E0E0DC"/>
+                      </a:solidFill>
+                      <a:prstDash val="solid"/>
+                      <a:round/>
+                      <a:headEnd type="none" w="med" len="med"/>
+                      <a:tailEnd type="none" w="med" len="med"/>
+                    </a:lnR>
+                    <a:lnT w="6350" cap="flat" cmpd="sng" algn="ctr">
+                      <a:solidFill>
+                        <a:srgbClr val="E0E0DC"/>
+                      </a:solidFill>
+                      <a:prstDash val="solid"/>
+                      <a:round/>
+                      <a:headEnd type="none" w="med" len="med"/>
+                      <a:tailEnd type="none" w="med" len="med"/>
+                    </a:lnT>
+                    <a:lnB w="6350" cap="flat" cmpd="sng" algn="ctr">
+                      <a:solidFill>
+                        <a:srgbClr val="E0E0DC"/>
+                      </a:solidFill>
+                      <a:prstDash val="solid"/>
+                      <a:round/>
+                      <a:headEnd type="none" w="med" len="med"/>
+                      <a:tailEnd type="none" w="med" len="med"/>
+                    </a:lnB>
+                    <a:solidFill>
+                      <a:srgbClr val="FFFFFF"/>
+                    </a:solidFill>
+                  </a:tcPr>
+                </a:tc>
+                <a:tc>
+                  <a:txBody>
+                    <a:bodyPr/>
+                    <a:lstStyle/>
+                    <a:p>
+                      <a:pPr marL="0" indent="0" algn="l">
+                        <a:buNone/>
+                      </a:pPr>
+                      <a:r>
+                        <a:rPr lang="en-US" sz="900" dirty="0">
+                          <a:solidFill>
+                            <a:srgbClr val="4D4D4D"/>
+                          </a:solidFill>
+                          <a:latin typeface="Calibri" pitchFamily="34" charset="0"/>
+                          <a:ea typeface="Calibri" pitchFamily="34" charset="-122"/>
+                          <a:cs typeface="Calibri" pitchFamily="34" charset="-120"/>
+                        </a:rPr>
+                        <a:t>key visual + adaptacje do formatów digital</a:t>
+                      </a:r>
+                      <a:endParaRPr lang="en-US" sz="900" dirty="0">
+                        <a:latin typeface="Calibri" charset="0"/>
+                        <a:ea typeface="Calibri" charset="0"/>
+                        <a:cs typeface="Calibri" charset="0"/>
+                      </a:endParaRPr>
+                    </a:p>
+                  </a:txBody>
+                  <a:tcPr marL="64008" marR="64008" marT="27432" marB="27432" anchor="ctr">
+                    <a:lnL w="6350" cap="flat" cmpd="sng" algn="ctr">
+                      <a:solidFill>
+                        <a:srgbClr val="E0E0DC"/>
+                      </a:solidFill>
+                      <a:prstDash val="solid"/>
+                      <a:round/>
+                      <a:headEnd type="none" w="med" len="med"/>
+                      <a:tailEnd type="none" w="med" len="med"/>
+                    </a:lnL>
+                    <a:lnR w="6350" cap="flat" cmpd="sng" algn="ctr">
+                      <a:solidFill>
+                        <a:srgbClr val="E0E0DC"/>
+                      </a:solidFill>
+                      <a:prstDash val="solid"/>
+                      <a:round/>
+                      <a:headEnd type="none" w="med" len="med"/>
+                      <a:tailEnd type="none" w="med" len="med"/>
+                    </a:lnR>
+                    <a:lnT w="6350" cap="flat" cmpd="sng" algn="ctr">
+                      <a:solidFill>
+                        <a:srgbClr val="E0E0DC"/>
+                      </a:solidFill>
+                      <a:prstDash val="solid"/>
+                      <a:round/>
+                      <a:headEnd type="none" w="med" len="med"/>
+                      <a:tailEnd type="none" w="med" len="med"/>
+                    </a:lnT>
+                    <a:lnB w="6350" cap="flat" cmpd="sng" algn="ctr">
+                      <a:solidFill>
+                        <a:srgbClr val="E0E0DC"/>
+                      </a:solidFill>
+                      <a:prstDash val="solid"/>
+                      <a:round/>
+                      <a:headEnd type="none" w="med" len="med"/>
+                      <a:tailEnd type="none" w="med" len="med"/>
+                    </a:lnB>
+                    <a:solidFill>
+                      <a:srgbClr val="FFFFFF"/>
+                    </a:solidFill>
+                  </a:tcPr>
+                </a:tc>
+              </a:tr>
+              <a:tr h="228600">
+                <a:tc>
+                  <a:txBody>
+                    <a:bodyPr/>
+                    <a:lstStyle/>
+                    <a:p>
+                      <a:pPr marL="0" indent="0" algn="l">
+                        <a:buNone/>
+                      </a:pPr>
+                      <a:r>
+                        <a:rPr lang="en-US" sz="900" b="1" dirty="0">
+                          <a:solidFill>
+                            <a:srgbClr val="111111"/>
+                          </a:solidFill>
+                          <a:latin typeface="Calibri" pitchFamily="34" charset="0"/>
+                          <a:ea typeface="Calibri" pitchFamily="34" charset="-122"/>
+                          <a:cs typeface="Calibri" pitchFamily="34" charset="-120"/>
+                        </a:rPr>
+                        <a:t>Kreacja – produkcja spotu AI</a:t>
+                      </a:r>
+                      <a:endParaRPr lang="en-US" sz="900" dirty="0">
+                        <a:latin typeface="Calibri" charset="0"/>
+                        <a:ea typeface="Calibri" charset="0"/>
+                        <a:cs typeface="Calibri" charset="0"/>
+                      </a:endParaRPr>
+                    </a:p>
+                  </a:txBody>
+                  <a:tcPr marL="64008" marR="64008" marT="27432" marB="27432" anchor="ctr">
+                    <a:lnL w="6350" cap="flat" cmpd="sng" algn="ctr">
+                      <a:solidFill>
+                        <a:srgbClr val="E0E0DC"/>
+                      </a:solidFill>
+                      <a:prstDash val="solid"/>
+                      <a:round/>
+                      <a:headEnd type="none" w="med" len="med"/>
+                      <a:tailEnd type="none" w="med" len="med"/>
+                    </a:lnL>
+                    <a:lnR w="6350" cap="flat" cmpd="sng" algn="ctr">
+                      <a:solidFill>
+                        <a:srgbClr val="E0E0DC"/>
+                      </a:solidFill>
+                      <a:prstDash val="solid"/>
+                      <a:round/>
+                      <a:headEnd type="none" w="med" len="med"/>
+                      <a:tailEnd type="none" w="med" len="med"/>
+                    </a:lnR>
+                    <a:lnT w="6350" cap="flat" cmpd="sng" algn="ctr">
+                      <a:solidFill>
+                        <a:srgbClr val="E0E0DC"/>
+                      </a:solidFill>
+                      <a:prstDash val="solid"/>
+                      <a:round/>
+                      <a:headEnd type="none" w="med" len="med"/>
+                      <a:tailEnd type="none" w="med" len="med"/>
+                    </a:lnT>
+                    <a:lnB w="6350" cap="flat" cmpd="sng" algn="ctr">
+                      <a:solidFill>
+                        <a:srgbClr val="E0E0DC"/>
+                      </a:solidFill>
+                      <a:prstDash val="solid"/>
+                      <a:round/>
+                      <a:headEnd type="none" w="med" len="med"/>
+                      <a:tailEnd type="none" w="med" len="med"/>
+                    </a:lnB>
+                    <a:solidFill>
+                      <a:srgbClr val="FFFFFF"/>
+                    </a:solidFill>
+                  </a:tcPr>
+                </a:tc>
+                <a:tc>
+                  <a:txBody>
+                    <a:bodyPr/>
+                    <a:lstStyle/>
+                    <a:p>
+                      <a:pPr marL="0" indent="0" algn="ctr">
+                        <a:buNone/>
+                      </a:pPr>
+                      <a:r>
+                        <a:rPr lang="en-US" sz="900" b="1" dirty="0">
+                          <a:solidFill>
+                            <a:srgbClr val="4D4D4D"/>
+                          </a:solidFill>
+                          <a:latin typeface="Calibri" pitchFamily="34" charset="0"/>
+                          <a:ea typeface="Calibri" pitchFamily="34" charset="-122"/>
+                          <a:cs typeface="Calibri" pitchFamily="34" charset="-120"/>
+                        </a:rPr>
+                        <a:t>40 000 zł</a:t>
+                      </a:r>
+                      <a:endParaRPr lang="en-US" sz="900" dirty="0">
+                        <a:latin typeface="Calibri" charset="0"/>
+                        <a:ea typeface="Calibri" charset="0"/>
+                        <a:cs typeface="Calibri" charset="0"/>
+                      </a:endParaRPr>
+                    </a:p>
+                  </a:txBody>
+                  <a:tcPr marL="64008" marR="64008" marT="27432" marB="27432" anchor="ctr">
+                    <a:lnL w="6350" cap="flat" cmpd="sng" algn="ctr">
+                      <a:solidFill>
+                        <a:srgbClr val="E0E0DC"/>
+                      </a:solidFill>
+                      <a:prstDash val="solid"/>
+                      <a:round/>
+                      <a:headEnd type="none" w="med" len="med"/>
+                      <a:tailEnd type="none" w="med" len="med"/>
+                    </a:lnL>
+                    <a:lnR w="6350" cap="flat" cmpd="sng" algn="ctr">
+                      <a:solidFill>
+                        <a:srgbClr val="E0E0DC"/>
+                      </a:solidFill>
+                      <a:prstDash val="solid"/>
+                      <a:round/>
+                      <a:headEnd type="none" w="med" len="med"/>
+                      <a:tailEnd type="none" w="med" len="med"/>
+                    </a:lnR>
+                    <a:lnT w="6350" cap="flat" cmpd="sng" algn="ctr">
+                      <a:solidFill>
+                        <a:srgbClr val="E0E0DC"/>
+                      </a:solidFill>
+                      <a:prstDash val="solid"/>
+                      <a:round/>
+                      <a:headEnd type="none" w="med" len="med"/>
+                      <a:tailEnd type="none" w="med" len="med"/>
+                    </a:lnT>
+                    <a:lnB w="6350" cap="flat" cmpd="sng" algn="ctr">
+                      <a:solidFill>
+                        <a:srgbClr val="E0E0DC"/>
+                      </a:solidFill>
+                      <a:prstDash val="solid"/>
+                      <a:round/>
+                      <a:headEnd type="none" w="med" len="med"/>
+                      <a:tailEnd type="none" w="med" len="med"/>
+                    </a:lnB>
+                    <a:solidFill>
+                      <a:srgbClr val="FFFFFF"/>
+                    </a:solidFill>
+                  </a:tcPr>
+                </a:tc>
+                <a:tc>
+                  <a:txBody>
+                    <a:bodyPr/>
+                    <a:lstStyle/>
+                    <a:p>
+                      <a:pPr marL="0" indent="0" algn="l">
+                        <a:buNone/>
+                      </a:pPr>
+                      <a:r>
+                        <a:rPr lang="en-US" sz="900" dirty="0">
+                          <a:solidFill>
+                            <a:srgbClr val="4D4D4D"/>
+                          </a:solidFill>
+                          <a:latin typeface="Calibri" pitchFamily="34" charset="0"/>
+                          <a:ea typeface="Calibri" pitchFamily="34" charset="-122"/>
+                          <a:cs typeface="Calibri" pitchFamily="34" charset="-120"/>
+                        </a:rPr>
+                        <a:t>film wizerunkowy kampanii (produkcja AI)</a:t>
+                      </a:r>
+                      <a:endParaRPr lang="en-US" sz="900" dirty="0">
+                        <a:latin typeface="Calibri" charset="0"/>
+                        <a:ea typeface="Calibri" charset="0"/>
+                        <a:cs typeface="Calibri" charset="0"/>
+                      </a:endParaRPr>
+                    </a:p>
+                  </a:txBody>
+                  <a:tcPr marL="64008" marR="64008" marT="27432" marB="27432" anchor="ctr">
+                    <a:lnL w="6350" cap="flat" cmpd="sng" algn="ctr">
+                      <a:solidFill>
+                        <a:srgbClr val="E0E0DC"/>
+                      </a:solidFill>
+                      <a:prstDash val="solid"/>
+                      <a:round/>
+                      <a:headEnd type="none" w="med" len="med"/>
+                      <a:tailEnd type="none" w="med" len="med"/>
+                    </a:lnL>
+                    <a:lnR w="6350" cap="flat" cmpd="sng" algn="ctr">
+                      <a:solidFill>
+                        <a:srgbClr val="E0E0DC"/>
+                      </a:solidFill>
+                      <a:prstDash val="solid"/>
+                      <a:round/>
+                      <a:headEnd type="none" w="med" len="med"/>
+                      <a:tailEnd type="none" w="med" len="med"/>
+                    </a:lnR>
+                    <a:lnT w="6350" cap="flat" cmpd="sng" algn="ctr">
+                      <a:solidFill>
+                        <a:srgbClr val="E0E0DC"/>
+                      </a:solidFill>
+                      <a:prstDash val="solid"/>
+                      <a:round/>
+                      <a:headEnd type="none" w="med" len="med"/>
+                      <a:tailEnd type="none" w="med" len="med"/>
+                    </a:lnT>
+                    <a:lnB w="6350" cap="flat" cmpd="sng" algn="ctr">
+                      <a:solidFill>
+                        <a:srgbClr val="E0E0DC"/>
+                      </a:solidFill>
+                      <a:prstDash val="solid"/>
+                      <a:round/>
+                      <a:headEnd type="none" w="med" len="med"/>
+                      <a:tailEnd type="none" w="med" len="med"/>
+                    </a:lnB>
+                    <a:solidFill>
+                      <a:srgbClr val="FFFFFF"/>
+                    </a:solidFill>
+                  </a:tcPr>
+                </a:tc>
+              </a:tr>
+              <a:tr h="228600">
+                <a:tc>
+                  <a:txBody>
+                    <a:bodyPr/>
+                    <a:lstStyle/>
+                    <a:p>
+                      <a:pPr marL="0" indent="0" algn="l">
+                        <a:buNone/>
+                      </a:pPr>
+                      <a:r>
+                        <a:rPr lang="en-US" sz="900" b="1" dirty="0">
+                          <a:solidFill>
+                            <a:srgbClr val="111111"/>
+                          </a:solidFill>
+                          <a:latin typeface="Calibri" pitchFamily="34" charset="0"/>
+                          <a:ea typeface="Calibri" pitchFamily="34" charset="-122"/>
+                          <a:cs typeface="Calibri" pitchFamily="34" charset="-120"/>
+                        </a:rPr>
+                        <a:t>Kreacja – KV + formaty: teaser</a:t>
+                      </a:r>
+                      <a:endParaRPr lang="en-US" sz="900" dirty="0">
+                        <a:latin typeface="Calibri" charset="0"/>
+                        <a:ea typeface="Calibri" charset="0"/>
+                        <a:cs typeface="Calibri" charset="0"/>
+                      </a:endParaRPr>
+                    </a:p>
+                  </a:txBody>
+                  <a:tcPr marL="64008" marR="64008" marT="27432" marB="27432" anchor="ctr">
+                    <a:lnL w="6350" cap="flat" cmpd="sng" algn="ctr">
+                      <a:solidFill>
+                        <a:srgbClr val="E0E0DC"/>
+                      </a:solidFill>
+                      <a:prstDash val="solid"/>
+                      <a:round/>
+                      <a:headEnd type="none" w="med" len="med"/>
+                      <a:tailEnd type="none" w="med" len="med"/>
+                    </a:lnL>
+                    <a:lnR w="6350" cap="flat" cmpd="sng" algn="ctr">
+                      <a:solidFill>
+                        <a:srgbClr val="E0E0DC"/>
+                      </a:solidFill>
+                      <a:prstDash val="solid"/>
+                      <a:round/>
+                      <a:headEnd type="none" w="med" len="med"/>
+                      <a:tailEnd type="none" w="med" len="med"/>
+                    </a:lnR>
+                    <a:lnT w="6350" cap="flat" cmpd="sng" algn="ctr">
+                      <a:solidFill>
+                        <a:srgbClr val="E0E0DC"/>
+                      </a:solidFill>
+                      <a:prstDash val="solid"/>
+                      <a:round/>
+                      <a:headEnd type="none" w="med" len="med"/>
+                      <a:tailEnd type="none" w="med" len="med"/>
+                    </a:lnT>
+                    <a:lnB w="6350" cap="flat" cmpd="sng" algn="ctr">
+                      <a:solidFill>
+                        <a:srgbClr val="E0E0DC"/>
+                      </a:solidFill>
+                      <a:prstDash val="solid"/>
+                      <a:round/>
+                      <a:headEnd type="none" w="med" len="med"/>
+                      <a:tailEnd type="none" w="med" len="med"/>
+                    </a:lnB>
+                    <a:solidFill>
+                      <a:srgbClr val="FFFFFF"/>
+                    </a:solidFill>
+                  </a:tcPr>
+                </a:tc>
+                <a:tc>
+                  <a:txBody>
+                    <a:bodyPr/>
+                    <a:lstStyle/>
+                    <a:p>
+                      <a:pPr marL="0" indent="0" algn="ctr">
+                        <a:buNone/>
+                      </a:pPr>
+                      <a:r>
+                        <a:rPr lang="en-US" sz="900" b="1" dirty="0">
+                          <a:solidFill>
+                            <a:srgbClr val="4D4D4D"/>
+                          </a:solidFill>
+                          <a:latin typeface="Calibri" pitchFamily="34" charset="0"/>
+                          <a:ea typeface="Calibri" pitchFamily="34" charset="-122"/>
+                          <a:cs typeface="Calibri" pitchFamily="34" charset="-120"/>
+                        </a:rPr>
+                        <a:t>8 000 zł</a:t>
+                      </a:r>
+                      <a:endParaRPr lang="en-US" sz="900" dirty="0">
+                        <a:latin typeface="Calibri" charset="0"/>
+                        <a:ea typeface="Calibri" charset="0"/>
+                        <a:cs typeface="Calibri" charset="0"/>
+                      </a:endParaRPr>
+                    </a:p>
+                  </a:txBody>
+                  <a:tcPr marL="64008" marR="64008" marT="27432" marB="27432" anchor="ctr">
+                    <a:lnL w="6350" cap="flat" cmpd="sng" algn="ctr">
+                      <a:solidFill>
+                        <a:srgbClr val="E0E0DC"/>
+                      </a:solidFill>
+                      <a:prstDash val="solid"/>
+                      <a:round/>
+                      <a:headEnd type="none" w="med" len="med"/>
+                      <a:tailEnd type="none" w="med" len="med"/>
+                    </a:lnL>
+                    <a:lnR w="6350" cap="flat" cmpd="sng" algn="ctr">
+                      <a:solidFill>
+                        <a:srgbClr val="E0E0DC"/>
+                      </a:solidFill>
+                      <a:prstDash val="solid"/>
+                      <a:round/>
+                      <a:headEnd type="none" w="med" len="med"/>
+                      <a:tailEnd type="none" w="med" len="med"/>
+                    </a:lnR>
+                    <a:lnT w="6350" cap="flat" cmpd="sng" algn="ctr">
+                      <a:solidFill>
+                        <a:srgbClr val="E0E0DC"/>
+                      </a:solidFill>
+                      <a:prstDash val="solid"/>
+                      <a:round/>
+                      <a:headEnd type="none" w="med" len="med"/>
+                      <a:tailEnd type="none" w="med" len="med"/>
+                    </a:lnT>
+                    <a:lnB w="6350" cap="flat" cmpd="sng" algn="ctr">
+                      <a:solidFill>
+                        <a:srgbClr val="E0E0DC"/>
+                      </a:solidFill>
+                      <a:prstDash val="solid"/>
+                      <a:round/>
+                      <a:headEnd type="none" w="med" len="med"/>
+                      <a:tailEnd type="none" w="med" len="med"/>
+                    </a:lnB>
+                    <a:solidFill>
+                      <a:srgbClr val="FFFFFF"/>
+                    </a:solidFill>
+                  </a:tcPr>
+                </a:tc>
+                <a:tc>
+                  <a:txBody>
+                    <a:bodyPr/>
+                    <a:lstStyle/>
+                    <a:p>
+                      <a:pPr marL="0" indent="0" algn="l">
+                        <a:buNone/>
+                      </a:pPr>
+                      <a:r>
+                        <a:rPr lang="en-US" sz="900" dirty="0">
+                          <a:solidFill>
+                            <a:srgbClr val="4D4D4D"/>
+                          </a:solidFill>
+                          <a:latin typeface="Calibri" pitchFamily="34" charset="0"/>
+                          <a:ea typeface="Calibri" pitchFamily="34" charset="-122"/>
+                          <a:cs typeface="Calibri" pitchFamily="34" charset="-120"/>
+                        </a:rPr>
+                        <a:t>etap I: teaser (19–25.10)</a:t>
+                      </a:r>
+                      <a:endParaRPr lang="en-US" sz="900" dirty="0">
+                        <a:latin typeface="Calibri" charset="0"/>
+                        <a:ea typeface="Calibri" charset="0"/>
+                        <a:cs typeface="Calibri" charset="0"/>
+                      </a:endParaRPr>
+                    </a:p>
+                  </a:txBody>
+                  <a:tcPr marL="64008" marR="64008" marT="27432" marB="27432" anchor="ctr">
+                    <a:lnL w="6350" cap="flat" cmpd="sng" algn="ctr">
+                      <a:solidFill>
+                        <a:srgbClr val="E0E0DC"/>
+                      </a:solidFill>
+                      <a:prstDash val="solid"/>
+                      <a:round/>
+                      <a:headEnd type="none" w="med" len="med"/>
+                      <a:tailEnd type="none" w="med" len="med"/>
+                    </a:lnL>
+                    <a:lnR w="6350" cap="flat" cmpd="sng" algn="ctr">
+                      <a:solidFill>
+                        <a:srgbClr val="E0E0DC"/>
+                      </a:solidFill>
+                      <a:prstDash val="solid"/>
+                      <a:round/>
+                      <a:headEnd type="none" w="med" len="med"/>
+                      <a:tailEnd type="none" w="med" len="med"/>
+                    </a:lnR>
+                    <a:lnT w="6350" cap="flat" cmpd="sng" algn="ctr">
+                      <a:solidFill>
+                        <a:srgbClr val="E0E0DC"/>
+                      </a:solidFill>
+                      <a:prstDash val="solid"/>
+                      <a:round/>
+                      <a:headEnd type="none" w="med" len="med"/>
+                      <a:tailEnd type="none" w="med" len="med"/>
+                    </a:lnT>
+                    <a:lnB w="6350" cap="flat" cmpd="sng" algn="ctr">
+                      <a:solidFill>
+                        <a:srgbClr val="E0E0DC"/>
+                      </a:solidFill>
+                      <a:prstDash val="solid"/>
+                      <a:round/>
+                      <a:headEnd type="none" w="med" len="med"/>
+                      <a:tailEnd type="none" w="med" len="med"/>
+                    </a:lnB>
+                    <a:solidFill>
+                      <a:srgbClr val="FFFFFF"/>
+                    </a:solidFill>
+                  </a:tcPr>
+                </a:tc>
+              </a:tr>
+              <a:tr h="228600">
+                <a:tc>
+                  <a:txBody>
+                    <a:bodyPr/>
+                    <a:lstStyle/>
+                    <a:p>
+                      <a:pPr marL="0" indent="0" algn="l">
+                        <a:buNone/>
+                      </a:pPr>
+                      <a:r>
+                        <a:rPr lang="en-US" sz="900" b="1" dirty="0">
+                          <a:solidFill>
+                            <a:srgbClr val="111111"/>
+                          </a:solidFill>
+                          <a:latin typeface="Calibri" pitchFamily="34" charset="0"/>
+                          <a:ea typeface="Calibri" pitchFamily="34" charset="-122"/>
+                          <a:cs typeface="Calibri" pitchFamily="34" charset="-120"/>
+                        </a:rPr>
+                        <a:t>Kreacja – KV + formaty: sprzedaż</a:t>
+                      </a:r>
+                      <a:endParaRPr lang="en-US" sz="900" dirty="0">
+                        <a:latin typeface="Calibri" charset="0"/>
+                        <a:ea typeface="Calibri" charset="0"/>
+                        <a:cs typeface="Calibri" charset="0"/>
+                      </a:endParaRPr>
+                    </a:p>
+                  </a:txBody>
+                  <a:tcPr marL="64008" marR="64008" marT="27432" marB="27432" anchor="ctr">
+                    <a:lnL w="6350" cap="flat" cmpd="sng" algn="ctr">
+                      <a:solidFill>
+                        <a:srgbClr val="E0E0DC"/>
+                      </a:solidFill>
+                      <a:prstDash val="solid"/>
+                      <a:round/>
+                      <a:headEnd type="none" w="med" len="med"/>
+                      <a:tailEnd type="none" w="med" len="med"/>
+                    </a:lnL>
+                    <a:lnR w="6350" cap="flat" cmpd="sng" algn="ctr">
+                      <a:solidFill>
+                        <a:srgbClr val="E0E0DC"/>
+                      </a:solidFill>
+                      <a:prstDash val="solid"/>
+                      <a:round/>
+                      <a:headEnd type="none" w="med" len="med"/>
+                      <a:tailEnd type="none" w="med" len="med"/>
+                    </a:lnR>
+                    <a:lnT w="6350" cap="flat" cmpd="sng" algn="ctr">
+                      <a:solidFill>
+                        <a:srgbClr val="E0E0DC"/>
+                      </a:solidFill>
+                      <a:prstDash val="solid"/>
+                      <a:round/>
+                      <a:headEnd type="none" w="med" len="med"/>
+                      <a:tailEnd type="none" w="med" len="med"/>
+                    </a:lnT>
+                    <a:lnB w="6350" cap="flat" cmpd="sng" algn="ctr">
+                      <a:solidFill>
+                        <a:srgbClr val="E0E0DC"/>
+                      </a:solidFill>
+                      <a:prstDash val="solid"/>
+                      <a:round/>
+                      <a:headEnd type="none" w="med" len="med"/>
+                      <a:tailEnd type="none" w="med" len="med"/>
+                    </a:lnB>
+                    <a:solidFill>
+                      <a:srgbClr val="FFFFFF"/>
+                    </a:solidFill>
+                  </a:tcPr>
+                </a:tc>
+                <a:tc>
+                  <a:txBody>
+                    <a:bodyPr/>
+                    <a:lstStyle/>
+                    <a:p>
+                      <a:pPr marL="0" indent="0" algn="ctr">
+                        <a:buNone/>
+                      </a:pPr>
+                      <a:r>
+                        <a:rPr lang="en-US" sz="900" b="1" dirty="0">
+                          <a:solidFill>
+                            <a:srgbClr val="4D4D4D"/>
+                          </a:solidFill>
+                          <a:latin typeface="Calibri" pitchFamily="34" charset="0"/>
+                          <a:ea typeface="Calibri" pitchFamily="34" charset="-122"/>
+                          <a:cs typeface="Calibri" pitchFamily="34" charset="-120"/>
+                        </a:rPr>
+                        <a:t>8 000 zł</a:t>
+                      </a:r>
+                      <a:endParaRPr lang="en-US" sz="900" dirty="0">
+                        <a:latin typeface="Calibri" charset="0"/>
+                        <a:ea typeface="Calibri" charset="0"/>
+                        <a:cs typeface="Calibri" charset="0"/>
+                      </a:endParaRPr>
+                    </a:p>
+                  </a:txBody>
+                  <a:tcPr marL="64008" marR="64008" marT="27432" marB="27432" anchor="ctr">
+                    <a:lnL w="6350" cap="flat" cmpd="sng" algn="ctr">
+                      <a:solidFill>
+                        <a:srgbClr val="E0E0DC"/>
+                      </a:solidFill>
+                      <a:prstDash val="solid"/>
+                      <a:round/>
+                      <a:headEnd type="none" w="med" len="med"/>
+                      <a:tailEnd type="none" w="med" len="med"/>
+                    </a:lnL>
+                    <a:lnR w="6350" cap="flat" cmpd="sng" algn="ctr">
+                      <a:solidFill>
+                        <a:srgbClr val="E0E0DC"/>
+                      </a:solidFill>
+                      <a:prstDash val="solid"/>
+                      <a:round/>
+                      <a:headEnd type="none" w="med" len="med"/>
+                      <a:tailEnd type="none" w="med" len="med"/>
+                    </a:lnR>
+                    <a:lnT w="6350" cap="flat" cmpd="sng" algn="ctr">
+                      <a:solidFill>
+                        <a:srgbClr val="E0E0DC"/>
+                      </a:solidFill>
+                      <a:prstDash val="solid"/>
+                      <a:round/>
+                      <a:headEnd type="none" w="med" len="med"/>
+                      <a:tailEnd type="none" w="med" len="med"/>
+                    </a:lnT>
+                    <a:lnB w="6350" cap="flat" cmpd="sng" algn="ctr">
+                      <a:solidFill>
+                        <a:srgbClr val="E0E0DC"/>
+                      </a:solidFill>
+                      <a:prstDash val="solid"/>
+                      <a:round/>
+                      <a:headEnd type="none" w="med" len="med"/>
+                      <a:tailEnd type="none" w="med" len="med"/>
+                    </a:lnB>
+                    <a:solidFill>
+                      <a:srgbClr val="FFFFFF"/>
+                    </a:solidFill>
+                  </a:tcPr>
+                </a:tc>
+                <a:tc>
+                  <a:txBody>
+                    <a:bodyPr/>
+                    <a:lstStyle/>
+                    <a:p>
+                      <a:pPr marL="0" indent="0" algn="l">
+                        <a:buNone/>
+                      </a:pPr>
+                      <a:r>
+                        <a:rPr lang="en-US" sz="900" dirty="0">
+                          <a:solidFill>
+                            <a:srgbClr val="4D4D4D"/>
+                          </a:solidFill>
+                          <a:latin typeface="Calibri" pitchFamily="34" charset="0"/>
+                          <a:ea typeface="Calibri" pitchFamily="34" charset="-122"/>
+                          <a:cs typeface="Calibri" pitchFamily="34" charset="-120"/>
+                        </a:rPr>
+                        <a:t>etap III: sprzedaż (8–29.11)</a:t>
+                      </a:r>
+                      <a:endParaRPr lang="en-US" sz="900" dirty="0">
+                        <a:latin typeface="Calibri" charset="0"/>
+                        <a:ea typeface="Calibri" charset="0"/>
+                        <a:cs typeface="Calibri" charset="0"/>
+                      </a:endParaRPr>
+                    </a:p>
+                  </a:txBody>
+                  <a:tcPr marL="64008" marR="64008" marT="27432" marB="27432" anchor="ctr">
+                    <a:lnL w="6350" cap="flat" cmpd="sng" algn="ctr">
+                      <a:solidFill>
+                        <a:srgbClr val="E0E0DC"/>
+                      </a:solidFill>
+                      <a:prstDash val="solid"/>
+                      <a:round/>
+                      <a:headEnd type="none" w="med" len="med"/>
+                      <a:tailEnd type="none" w="med" len="med"/>
+                    </a:lnL>
+                    <a:lnR w="6350" cap="flat" cmpd="sng" algn="ctr">
+                      <a:solidFill>
+                        <a:srgbClr val="E0E0DC"/>
+                      </a:solidFill>
+                      <a:prstDash val="solid"/>
+                      <a:round/>
+                      <a:headEnd type="none" w="med" len="med"/>
+                      <a:tailEnd type="none" w="med" len="med"/>
+                    </a:lnR>
+                    <a:lnT w="6350" cap="flat" cmpd="sng" algn="ctr">
+                      <a:solidFill>
+                        <a:srgbClr val="E0E0DC"/>
+                      </a:solidFill>
+                      <a:prstDash val="solid"/>
+                      <a:round/>
+                      <a:headEnd type="none" w="med" len="med"/>
+                      <a:tailEnd type="none" w="med" len="med"/>
+                    </a:lnT>
+                    <a:lnB w="6350" cap="flat" cmpd="sng" algn="ctr">
+                      <a:solidFill>
+                        <a:srgbClr val="E0E0DC"/>
+                      </a:solidFill>
+                      <a:prstDash val="solid"/>
+                      <a:round/>
+                      <a:headEnd type="none" w="med" len="med"/>
+                      <a:tailEnd type="none" w="med" len="med"/>
+                    </a:lnB>
+                    <a:solidFill>
+                      <a:srgbClr val="FFFFFF"/>
+                    </a:solidFill>
+                  </a:tcPr>
+                </a:tc>
+              </a:tr>
+              <a:tr h="228600">
+                <a:tc>
+                  <a:txBody>
+                    <a:bodyPr/>
+                    <a:lstStyle/>
+                    <a:p>
+                      <a:pPr marL="0" indent="0" algn="l">
+                        <a:buNone/>
+                      </a:pPr>
+                      <a:r>
+                        <a:rPr lang="en-US" sz="900" b="1" dirty="0">
+                          <a:solidFill>
+                            <a:srgbClr val="111111"/>
+                          </a:solidFill>
+                          <a:latin typeface="Calibri" pitchFamily="34" charset="0"/>
+                          <a:ea typeface="Calibri" pitchFamily="34" charset="-122"/>
+                          <a:cs typeface="Calibri" pitchFamily="34" charset="-120"/>
+                        </a:rPr>
+                        <a:t>Kreacja – produkcja animacji: teaser</a:t>
+                      </a:r>
+                      <a:endParaRPr lang="en-US" sz="900" dirty="0">
+                        <a:latin typeface="Calibri" charset="0"/>
+                        <a:ea typeface="Calibri" charset="0"/>
+                        <a:cs typeface="Calibri" charset="0"/>
+                      </a:endParaRPr>
+                    </a:p>
+                  </a:txBody>
+                  <a:tcPr marL="64008" marR="64008" marT="27432" marB="27432" anchor="ctr">
+                    <a:lnL w="6350" cap="flat" cmpd="sng" algn="ctr">
+                      <a:solidFill>
+                        <a:srgbClr val="E0E0DC"/>
+                      </a:solidFill>
+                      <a:prstDash val="solid"/>
+                      <a:round/>
+                      <a:headEnd type="none" w="med" len="med"/>
+                      <a:tailEnd type="none" w="med" len="med"/>
+                    </a:lnL>
+                    <a:lnR w="6350" cap="flat" cmpd="sng" algn="ctr">
+                      <a:solidFill>
+                        <a:srgbClr val="E0E0DC"/>
+                      </a:solidFill>
+                      <a:prstDash val="solid"/>
+                      <a:round/>
+                      <a:headEnd type="none" w="med" len="med"/>
+                      <a:tailEnd type="none" w="med" len="med"/>
+                    </a:lnR>
+                    <a:lnT w="6350" cap="flat" cmpd="sng" algn="ctr">
+                      <a:solidFill>
+                        <a:srgbClr val="E0E0DC"/>
+                      </a:solidFill>
+                      <a:prstDash val="solid"/>
+                      <a:round/>
+                      <a:headEnd type="none" w="med" len="med"/>
+                      <a:tailEnd type="none" w="med" len="med"/>
+                    </a:lnT>
+                    <a:lnB w="6350" cap="flat" cmpd="sng" algn="ctr">
+                      <a:solidFill>
+                        <a:srgbClr val="E0E0DC"/>
+                      </a:solidFill>
+                      <a:prstDash val="solid"/>
+                      <a:round/>
+                      <a:headEnd type="none" w="med" len="med"/>
+                      <a:tailEnd type="none" w="med" len="med"/>
+                    </a:lnB>
+                    <a:solidFill>
+                      <a:srgbClr val="FFFFFF"/>
+                    </a:solidFill>
+                  </a:tcPr>
+                </a:tc>
+                <a:tc>
+                  <a:txBody>
+                    <a:bodyPr/>
+                    <a:lstStyle/>
+                    <a:p>
+                      <a:pPr marL="0" indent="0" algn="ctr">
+                        <a:buNone/>
+                      </a:pPr>
+                      <a:r>
+                        <a:rPr lang="en-US" sz="900" b="1" dirty="0">
+                          <a:solidFill>
+                            <a:srgbClr val="4D4D4D"/>
+                          </a:solidFill>
+                          <a:latin typeface="Calibri" pitchFamily="34" charset="0"/>
+                          <a:ea typeface="Calibri" pitchFamily="34" charset="-122"/>
+                          <a:cs typeface="Calibri" pitchFamily="34" charset="-120"/>
+                        </a:rPr>
+                        <a:t>4 000 zł</a:t>
+                      </a:r>
+                      <a:endParaRPr lang="en-US" sz="900" dirty="0">
+                        <a:latin typeface="Calibri" charset="0"/>
+                        <a:ea typeface="Calibri" charset="0"/>
+                        <a:cs typeface="Calibri" charset="0"/>
+                      </a:endParaRPr>
+                    </a:p>
+                  </a:txBody>
+                  <a:tcPr marL="64008" marR="64008" marT="27432" marB="27432" anchor="ctr">
+                    <a:lnL w="6350" cap="flat" cmpd="sng" algn="ctr">
+                      <a:solidFill>
+                        <a:srgbClr val="E0E0DC"/>
+                      </a:solidFill>
+                      <a:prstDash val="solid"/>
+                      <a:round/>
+                      <a:headEnd type="none" w="med" len="med"/>
+                      <a:tailEnd type="none" w="med" len="med"/>
+                    </a:lnL>
+                    <a:lnR w="6350" cap="flat" cmpd="sng" algn="ctr">
+                      <a:solidFill>
+                        <a:srgbClr val="E0E0DC"/>
+                      </a:solidFill>
+                      <a:prstDash val="solid"/>
+                      <a:round/>
+                      <a:headEnd type="none" w="med" len="med"/>
+                      <a:tailEnd type="none" w="med" len="med"/>
+                    </a:lnR>
+                    <a:lnT w="6350" cap="flat" cmpd="sng" algn="ctr">
+                      <a:solidFill>
+                        <a:srgbClr val="E0E0DC"/>
+                      </a:solidFill>
+                      <a:prstDash val="solid"/>
+                      <a:round/>
+                      <a:headEnd type="none" w="med" len="med"/>
+                      <a:tailEnd type="none" w="med" len="med"/>
+                    </a:lnT>
+                    <a:lnB w="6350" cap="flat" cmpd="sng" algn="ctr">
+                      <a:solidFill>
+                        <a:srgbClr val="E0E0DC"/>
+                      </a:solidFill>
+                      <a:prstDash val="solid"/>
+                      <a:round/>
+                      <a:headEnd type="none" w="med" len="med"/>
+                      <a:tailEnd type="none" w="med" len="med"/>
+                    </a:lnB>
+                    <a:solidFill>
+                      <a:srgbClr val="FFFFFF"/>
+                    </a:solidFill>
+                  </a:tcPr>
+                </a:tc>
+                <a:tc>
+                  <a:txBody>
+                    <a:bodyPr/>
+                    <a:lstStyle/>
+                    <a:p>
+                      <a:pPr marL="0" indent="0" algn="l">
+                        <a:buNone/>
+                      </a:pPr>
+                      <a:r>
+                        <a:rPr lang="en-US" sz="900" dirty="0">
+                          <a:solidFill>
+                            <a:srgbClr val="4D4D4D"/>
+                          </a:solidFill>
+                          <a:latin typeface="Calibri" pitchFamily="34" charset="0"/>
+                          <a:ea typeface="Calibri" pitchFamily="34" charset="-122"/>
+                          <a:cs typeface="Calibri" pitchFamily="34" charset="-120"/>
+                        </a:rPr>
+                        <a:t>animacja do etapu teaserowego</a:t>
+                      </a:r>
+                      <a:endParaRPr lang="en-US" sz="900" dirty="0">
+                        <a:latin typeface="Calibri" charset="0"/>
+                        <a:ea typeface="Calibri" charset="0"/>
+                        <a:cs typeface="Calibri" charset="0"/>
+                      </a:endParaRPr>
+                    </a:p>
+                  </a:txBody>
+                  <a:tcPr marL="64008" marR="64008" marT="27432" marB="27432" anchor="ctr">
+                    <a:lnL w="6350" cap="flat" cmpd="sng" algn="ctr">
+                      <a:solidFill>
+                        <a:srgbClr val="E0E0DC"/>
+                      </a:solidFill>
+                      <a:prstDash val="solid"/>
+                      <a:round/>
+                      <a:headEnd type="none" w="med" len="med"/>
+                      <a:tailEnd type="none" w="med" len="med"/>
+                    </a:lnL>
+                    <a:lnR w="6350" cap="flat" cmpd="sng" algn="ctr">
+                      <a:solidFill>
+                        <a:srgbClr val="E0E0DC"/>
+                      </a:solidFill>
+                      <a:prstDash val="solid"/>
+                      <a:round/>
+                      <a:headEnd type="none" w="med" len="med"/>
+                      <a:tailEnd type="none" w="med" len="med"/>
+                    </a:lnR>
+                    <a:lnT w="6350" cap="flat" cmpd="sng" algn="ctr">
+                      <a:solidFill>
+                        <a:srgbClr val="E0E0DC"/>
+                      </a:solidFill>
+                      <a:prstDash val="solid"/>
+                      <a:round/>
+                      <a:headEnd type="none" w="med" len="med"/>
+                      <a:tailEnd type="none" w="med" len="med"/>
+                    </a:lnT>
+                    <a:lnB w="6350" cap="flat" cmpd="sng" algn="ctr">
+                      <a:solidFill>
+                        <a:srgbClr val="E0E0DC"/>
+                      </a:solidFill>
+                      <a:prstDash val="solid"/>
+                      <a:round/>
+                      <a:headEnd type="none" w="med" len="med"/>
+                      <a:tailEnd type="none" w="med" len="med"/>
+                    </a:lnB>
+                    <a:solidFill>
+                      <a:srgbClr val="FFFFFF"/>
+                    </a:solidFill>
+                  </a:tcPr>
+                </a:tc>
+              </a:tr>
+              <a:tr h="228600">
+                <a:tc>
+                  <a:txBody>
+                    <a:bodyPr/>
+                    <a:lstStyle/>
+                    <a:p>
+                      <a:pPr marL="0" indent="0" algn="l">
+                        <a:buNone/>
+                      </a:pPr>
+                      <a:r>
+                        <a:rPr lang="en-US" sz="900" b="1" dirty="0">
+                          <a:solidFill>
+                            <a:srgbClr val="111111"/>
+                          </a:solidFill>
+                          <a:latin typeface="Calibri" pitchFamily="34" charset="0"/>
+                          <a:ea typeface="Calibri" pitchFamily="34" charset="-122"/>
+                          <a:cs typeface="Calibri" pitchFamily="34" charset="-120"/>
+                        </a:rPr>
+                        <a:t>Kreacja – rolki i animacje: sprzedaż</a:t>
+                      </a:r>
+                      <a:endParaRPr lang="en-US" sz="900" dirty="0">
+                        <a:latin typeface="Calibri" charset="0"/>
+                        <a:ea typeface="Calibri" charset="0"/>
+                        <a:cs typeface="Calibri" charset="0"/>
+                      </a:endParaRPr>
+                    </a:p>
+                  </a:txBody>
+                  <a:tcPr marL="64008" marR="64008" marT="27432" marB="27432" anchor="ctr">
+                    <a:lnL w="6350" cap="flat" cmpd="sng" algn="ctr">
+                      <a:solidFill>
+                        <a:srgbClr val="E0E0DC"/>
+                      </a:solidFill>
+                      <a:prstDash val="solid"/>
+                      <a:round/>
+                      <a:headEnd type="none" w="med" len="med"/>
+                      <a:tailEnd type="none" w="med" len="med"/>
+                    </a:lnL>
+                    <a:lnR w="6350" cap="flat" cmpd="sng" algn="ctr">
+                      <a:solidFill>
+                        <a:srgbClr val="E0E0DC"/>
+                      </a:solidFill>
+                      <a:prstDash val="solid"/>
+                      <a:round/>
+                      <a:headEnd type="none" w="med" len="med"/>
+                      <a:tailEnd type="none" w="med" len="med"/>
+                    </a:lnR>
+                    <a:lnT w="6350" cap="flat" cmpd="sng" algn="ctr">
+                      <a:solidFill>
+                        <a:srgbClr val="E0E0DC"/>
+                      </a:solidFill>
+                      <a:prstDash val="solid"/>
+                      <a:round/>
+                      <a:headEnd type="none" w="med" len="med"/>
+                      <a:tailEnd type="none" w="med" len="med"/>
+                    </a:lnT>
+                    <a:lnB w="6350" cap="flat" cmpd="sng" algn="ctr">
+                      <a:solidFill>
+                        <a:srgbClr val="E0E0DC"/>
+                      </a:solidFill>
+                      <a:prstDash val="solid"/>
+                      <a:round/>
+                      <a:headEnd type="none" w="med" len="med"/>
+                      <a:tailEnd type="none" w="med" len="med"/>
+                    </a:lnB>
+                    <a:solidFill>
+                      <a:srgbClr val="FFFFFF"/>
+                    </a:solidFill>
+                  </a:tcPr>
+                </a:tc>
+                <a:tc>
+                  <a:txBody>
+                    <a:bodyPr/>
+                    <a:lstStyle/>
+                    <a:p>
+                      <a:pPr marL="0" indent="0" algn="ctr">
+                        <a:buNone/>
+                      </a:pPr>
+                      <a:r>
+                        <a:rPr lang="en-US" sz="900" b="1" dirty="0">
+                          <a:solidFill>
+                            <a:srgbClr val="4D4D4D"/>
+                          </a:solidFill>
+                          <a:latin typeface="Calibri" pitchFamily="34" charset="0"/>
+                          <a:ea typeface="Calibri" pitchFamily="34" charset="-122"/>
+                          <a:cs typeface="Calibri" pitchFamily="34" charset="-120"/>
+                        </a:rPr>
+                        <a:t>8 000 zł</a:t>
+                      </a:r>
+                      <a:endParaRPr lang="en-US" sz="900" dirty="0">
+                        <a:latin typeface="Calibri" charset="0"/>
+                        <a:ea typeface="Calibri" charset="0"/>
+                        <a:cs typeface="Calibri" charset="0"/>
+                      </a:endParaRPr>
+                    </a:p>
+                  </a:txBody>
+                  <a:tcPr marL="64008" marR="64008" marT="27432" marB="27432" anchor="ctr">
+                    <a:lnL w="6350" cap="flat" cmpd="sng" algn="ctr">
+                      <a:solidFill>
+                        <a:srgbClr val="E0E0DC"/>
+                      </a:solidFill>
+                      <a:prstDash val="solid"/>
+                      <a:round/>
+                      <a:headEnd type="none" w="med" len="med"/>
+                      <a:tailEnd type="none" w="med" len="med"/>
+                    </a:lnL>
+                    <a:lnR w="6350" cap="flat" cmpd="sng" algn="ctr">
+                      <a:solidFill>
+                        <a:srgbClr val="E0E0DC"/>
+                      </a:solidFill>
+                      <a:prstDash val="solid"/>
+                      <a:round/>
+                      <a:headEnd type="none" w="med" len="med"/>
+                      <a:tailEnd type="none" w="med" len="med"/>
+                    </a:lnR>
+                    <a:lnT w="6350" cap="flat" cmpd="sng" algn="ctr">
+                      <a:solidFill>
+                        <a:srgbClr val="E0E0DC"/>
+                      </a:solidFill>
+                      <a:prstDash val="solid"/>
+                      <a:round/>
+                      <a:headEnd type="none" w="med" len="med"/>
+                      <a:tailEnd type="none" w="med" len="med"/>
+                    </a:lnT>
+                    <a:lnB w="6350" cap="flat" cmpd="sng" algn="ctr">
+                      <a:solidFill>
+                        <a:srgbClr val="E0E0DC"/>
+                      </a:solidFill>
+                      <a:prstDash val="solid"/>
+                      <a:round/>
+                      <a:headEnd type="none" w="med" len="med"/>
+                      <a:tailEnd type="none" w="med" len="med"/>
+                    </a:lnB>
+                    <a:solidFill>
+                      <a:srgbClr val="FFFFFF"/>
+                    </a:solidFill>
+                  </a:tcPr>
+                </a:tc>
+                <a:tc>
+                  <a:txBody>
+                    <a:bodyPr/>
+                    <a:lstStyle/>
+                    <a:p>
+                      <a:pPr marL="0" indent="0" algn="l">
+                        <a:buNone/>
+                      </a:pPr>
+                      <a:r>
+                        <a:rPr lang="en-US" sz="900" dirty="0">
+                          <a:solidFill>
+                            <a:srgbClr val="4D4D4D"/>
+                          </a:solidFill>
+                          <a:latin typeface="Calibri" pitchFamily="34" charset="0"/>
+                          <a:ea typeface="Calibri" pitchFamily="34" charset="-122"/>
+                          <a:cs typeface="Calibri" pitchFamily="34" charset="-120"/>
+                        </a:rPr>
+                        <a:t>produkcja rolek i animacji do etapu sprzedażowego</a:t>
+                      </a:r>
+                      <a:endParaRPr lang="en-US" sz="900" dirty="0">
+                        <a:latin typeface="Calibri" charset="0"/>
+                        <a:ea typeface="Calibri" charset="0"/>
+                        <a:cs typeface="Calibri" charset="0"/>
+                      </a:endParaRPr>
+                    </a:p>
+                  </a:txBody>
+                  <a:tcPr marL="64008" marR="64008" marT="27432" marB="27432" anchor="ctr">
+                    <a:lnL w="6350" cap="flat" cmpd="sng" algn="ctr">
+                      <a:solidFill>
+                        <a:srgbClr val="E0E0DC"/>
+                      </a:solidFill>
+                      <a:prstDash val="solid"/>
+                      <a:round/>
+                      <a:headEnd type="none" w="med" len="med"/>
+                      <a:tailEnd type="none" w="med" len="med"/>
+                    </a:lnL>
+                    <a:lnR w="6350" cap="flat" cmpd="sng" algn="ctr">
+                      <a:solidFill>
+                        <a:srgbClr val="E0E0DC"/>
+                      </a:solidFill>
+                      <a:prstDash val="solid"/>
+                      <a:round/>
+                      <a:headEnd type="none" w="med" len="med"/>
+                      <a:tailEnd type="none" w="med" len="med"/>
+                    </a:lnR>
+                    <a:lnT w="6350" cap="flat" cmpd="sng" algn="ctr">
+                      <a:solidFill>
+                        <a:srgbClr val="E0E0DC"/>
+                      </a:solidFill>
+                      <a:prstDash val="solid"/>
+                      <a:round/>
+                      <a:headEnd type="none" w="med" len="med"/>
+                      <a:tailEnd type="none" w="med" len="med"/>
+                    </a:lnT>
+                    <a:lnB w="6350" cap="flat" cmpd="sng" algn="ctr">
+                      <a:solidFill>
+                        <a:srgbClr val="E0E0DC"/>
+                      </a:solidFill>
+                      <a:prstDash val="solid"/>
+                      <a:round/>
+                      <a:headEnd type="none" w="med" len="med"/>
+                      <a:tailEnd type="none" w="med" len="med"/>
+                    </a:lnB>
+                    <a:solidFill>
+                      <a:srgbClr val="FFFFFF"/>
+                    </a:solidFill>
+                  </a:tcPr>
+                </a:tc>
+              </a:tr>
+              <a:tr h="228600">
+                <a:tc>
+                  <a:txBody>
+                    <a:bodyPr/>
+                    <a:lstStyle/>
+                    <a:p>
+                      <a:pPr marL="0" indent="0" algn="l">
+                        <a:buNone/>
+                      </a:pPr>
+                      <a:r>
+                        <a:rPr lang="en-US" sz="900" b="1" dirty="0">
+                          <a:solidFill>
+                            <a:srgbClr val="111111"/>
+                          </a:solidFill>
+                          <a:latin typeface="Calibri" pitchFamily="34" charset="0"/>
+                          <a:ea typeface="Calibri" pitchFamily="34" charset="-122"/>
+                          <a:cs typeface="Calibri" pitchFamily="34" charset="-120"/>
+                        </a:rPr>
+                        <a:t>Obsługa agencji – koordynacja akcji</a:t>
+                      </a:r>
+                      <a:endParaRPr lang="en-US" sz="900" dirty="0">
+                        <a:latin typeface="Calibri" charset="0"/>
+                        <a:ea typeface="Calibri" charset="0"/>
+                        <a:cs typeface="Calibri" charset="0"/>
+                      </a:endParaRPr>
+                    </a:p>
+                  </a:txBody>
+                  <a:tcPr marL="64008" marR="64008" marT="27432" marB="27432" anchor="ctr">
+                    <a:lnL w="6350" cap="flat" cmpd="sng" algn="ctr">
+                      <a:solidFill>
+                        <a:srgbClr val="E0E0DC"/>
+                      </a:solidFill>
+                      <a:prstDash val="solid"/>
+                      <a:round/>
+                      <a:headEnd type="none" w="med" len="med"/>
+                      <a:tailEnd type="none" w="med" len="med"/>
+                    </a:lnL>
+                    <a:lnR w="6350" cap="flat" cmpd="sng" algn="ctr">
+                      <a:solidFill>
+                        <a:srgbClr val="E0E0DC"/>
+                      </a:solidFill>
+                      <a:prstDash val="solid"/>
+                      <a:round/>
+                      <a:headEnd type="none" w="med" len="med"/>
+                      <a:tailEnd type="none" w="med" len="med"/>
+                    </a:lnR>
+                    <a:lnT w="6350" cap="flat" cmpd="sng" algn="ctr">
+                      <a:solidFill>
+                        <a:srgbClr val="E0E0DC"/>
+                      </a:solidFill>
+                      <a:prstDash val="solid"/>
+                      <a:round/>
+                      <a:headEnd type="none" w="med" len="med"/>
+                      <a:tailEnd type="none" w="med" len="med"/>
+                    </a:lnT>
+                    <a:lnB w="6350" cap="flat" cmpd="sng" algn="ctr">
+                      <a:solidFill>
+                        <a:srgbClr val="E0E0DC"/>
+                      </a:solidFill>
+                      <a:prstDash val="solid"/>
+                      <a:round/>
+                      <a:headEnd type="none" w="med" len="med"/>
+                      <a:tailEnd type="none" w="med" len="med"/>
+                    </a:lnB>
+                    <a:solidFill>
+                      <a:srgbClr val="FFFFFF"/>
+                    </a:solidFill>
+                  </a:tcPr>
+                </a:tc>
+                <a:tc>
+                  <a:txBody>
+                    <a:bodyPr/>
+                    <a:lstStyle/>
+                    <a:p>
+                      <a:pPr marL="0" indent="0" algn="ctr">
+                        <a:buNone/>
+                      </a:pPr>
+                      <a:r>
+                        <a:rPr lang="en-US" sz="900" b="1" dirty="0">
+                          <a:solidFill>
+                            <a:srgbClr val="4D4D4D"/>
+                          </a:solidFill>
+                          <a:latin typeface="Calibri" pitchFamily="34" charset="0"/>
+                          <a:ea typeface="Calibri" pitchFamily="34" charset="-122"/>
+                          <a:cs typeface="Calibri" pitchFamily="34" charset="-120"/>
+                        </a:rPr>
+                        <a:t>37 500 zł</a:t>
+                      </a:r>
+                      <a:endParaRPr lang="en-US" sz="900" dirty="0">
+                        <a:latin typeface="Calibri" charset="0"/>
+                        <a:ea typeface="Calibri" charset="0"/>
+                        <a:cs typeface="Calibri" charset="0"/>
+                      </a:endParaRPr>
+                    </a:p>
+                  </a:txBody>
+                  <a:tcPr marL="64008" marR="64008" marT="27432" marB="27432" anchor="ctr">
+                    <a:lnL w="6350" cap="flat" cmpd="sng" algn="ctr">
+                      <a:solidFill>
+                        <a:srgbClr val="E0E0DC"/>
+                      </a:solidFill>
+                      <a:prstDash val="solid"/>
+                      <a:round/>
+                      <a:headEnd type="none" w="med" len="med"/>
+                      <a:tailEnd type="none" w="med" len="med"/>
+                    </a:lnL>
+                    <a:lnR w="6350" cap="flat" cmpd="sng" algn="ctr">
+                      <a:solidFill>
+                        <a:srgbClr val="E0E0DC"/>
+                      </a:solidFill>
+                      <a:prstDash val="solid"/>
+                      <a:round/>
+                      <a:headEnd type="none" w="med" len="med"/>
+                      <a:tailEnd type="none" w="med" len="med"/>
+                    </a:lnR>
+                    <a:lnT w="6350" cap="flat" cmpd="sng" algn="ctr">
+                      <a:solidFill>
+                        <a:srgbClr val="E0E0DC"/>
+                      </a:solidFill>
+                      <a:prstDash val="solid"/>
+                      <a:round/>
+                      <a:headEnd type="none" w="med" len="med"/>
+                      <a:tailEnd type="none" w="med" len="med"/>
+                    </a:lnT>
+                    <a:lnB w="6350" cap="flat" cmpd="sng" algn="ctr">
+                      <a:solidFill>
+                        <a:srgbClr val="E0E0DC"/>
+                      </a:solidFill>
+                      <a:prstDash val="solid"/>
+                      <a:round/>
+                      <a:headEnd type="none" w="med" len="med"/>
+                      <a:tailEnd type="none" w="med" len="med"/>
+                    </a:lnB>
+                    <a:solidFill>
+                      <a:srgbClr val="FFFFFF"/>
+                    </a:solidFill>
+                  </a:tcPr>
+                </a:tc>
+                <a:tc>
+                  <a:txBody>
+                    <a:bodyPr/>
+                    <a:lstStyle/>
+                    <a:p>
+                      <a:pPr marL="0" indent="0" algn="l">
+                        <a:buNone/>
+                      </a:pPr>
+                      <a:r>
+                        <a:rPr lang="en-US" sz="900" dirty="0">
+                          <a:solidFill>
+                            <a:srgbClr val="4D4D4D"/>
+                          </a:solidFill>
+                          <a:latin typeface="Calibri" pitchFamily="34" charset="0"/>
+                          <a:ea typeface="Calibri" pitchFamily="34" charset="-122"/>
+                          <a:cs typeface="Calibri" pitchFamily="34" charset="-120"/>
+                        </a:rPr>
+                        <a:t>podwykonawcy itd.: 6 tyg. przygotowań + 6 tyg. akcji + 3 tyg. po</a:t>
+                      </a:r>
+                      <a:endParaRPr lang="en-US" sz="900" dirty="0">
+                        <a:latin typeface="Calibri" charset="0"/>
+                        <a:ea typeface="Calibri" charset="0"/>
+                        <a:cs typeface="Calibri" charset="0"/>
+                      </a:endParaRPr>
+                    </a:p>
+                  </a:txBody>
+                  <a:tcPr marL="64008" marR="64008" marT="27432" marB="27432" anchor="ctr">
+                    <a:lnL w="6350" cap="flat" cmpd="sng" algn="ctr">
+                      <a:solidFill>
+                        <a:srgbClr val="E0E0DC"/>
+                      </a:solidFill>
+                      <a:prstDash val="solid"/>
+                      <a:round/>
+                      <a:headEnd type="none" w="med" len="med"/>
+                      <a:tailEnd type="none" w="med" len="med"/>
+                    </a:lnL>
+                    <a:lnR w="6350" cap="flat" cmpd="sng" algn="ctr">
+                      <a:solidFill>
+                        <a:srgbClr val="E0E0DC"/>
+                      </a:solidFill>
+                      <a:prstDash val="solid"/>
+                      <a:round/>
+                      <a:headEnd type="none" w="med" len="med"/>
+                      <a:tailEnd type="none" w="med" len="med"/>
+                    </a:lnR>
+                    <a:lnT w="6350" cap="flat" cmpd="sng" algn="ctr">
+                      <a:solidFill>
+                        <a:srgbClr val="E0E0DC"/>
+                      </a:solidFill>
+                      <a:prstDash val="solid"/>
+                      <a:round/>
+                      <a:headEnd type="none" w="med" len="med"/>
+                      <a:tailEnd type="none" w="med" len="med"/>
+                    </a:lnT>
+                    <a:lnB w="6350" cap="flat" cmpd="sng" algn="ctr">
+                      <a:solidFill>
+                        <a:srgbClr val="E0E0DC"/>
+                      </a:solidFill>
+                      <a:prstDash val="solid"/>
+                      <a:round/>
+                      <a:headEnd type="none" w="med" len="med"/>
+                      <a:tailEnd type="none" w="med" len="med"/>
+                    </a:lnB>
+                    <a:solidFill>
+                      <a:srgbClr val="FFFFFF"/>
+                    </a:solidFill>
+                  </a:tcPr>
+                </a:tc>
+              </a:tr>
+              <a:tr h="228600">
+                <a:tc>
+                  <a:txBody>
+                    <a:bodyPr/>
+                    <a:lstStyle/>
+                    <a:p>
+                      <a:pPr marL="0" indent="0" algn="l">
+                        <a:buNone/>
+                      </a:pPr>
+                      <a:r>
+                        <a:rPr lang="en-US" sz="900" b="1" dirty="0">
+                          <a:solidFill>
+                            <a:srgbClr val="111111"/>
+                          </a:solidFill>
+                          <a:latin typeface="Calibri" pitchFamily="34" charset="0"/>
+                          <a:ea typeface="Calibri" pitchFamily="34" charset="-122"/>
+                          <a:cs typeface="Calibri" pitchFamily="34" charset="-120"/>
+                        </a:rPr>
+                        <a:t>Landing page</a:t>
+                      </a:r>
+                      <a:endParaRPr lang="en-US" sz="900" dirty="0">
+                        <a:latin typeface="Calibri" charset="0"/>
+                        <a:ea typeface="Calibri" charset="0"/>
+                        <a:cs typeface="Calibri" charset="0"/>
+                      </a:endParaRPr>
+                    </a:p>
+                  </a:txBody>
+                  <a:tcPr marL="64008" marR="64008" marT="27432" marB="27432" anchor="ctr">
+                    <a:lnL w="6350" cap="flat" cmpd="sng" algn="ctr">
+                      <a:solidFill>
+                        <a:srgbClr val="E0E0DC"/>
+                      </a:solidFill>
+                      <a:prstDash val="solid"/>
+                      <a:round/>
+                      <a:headEnd type="none" w="med" len="med"/>
+                      <a:tailEnd type="none" w="med" len="med"/>
+                    </a:lnL>
+                    <a:lnR w="6350" cap="flat" cmpd="sng" algn="ctr">
+                      <a:solidFill>
+                        <a:srgbClr val="E0E0DC"/>
+                      </a:solidFill>
+                      <a:prstDash val="solid"/>
+                      <a:round/>
+                      <a:headEnd type="none" w="med" len="med"/>
+                      <a:tailEnd type="none" w="med" len="med"/>
+                    </a:lnR>
+                    <a:lnT w="6350" cap="flat" cmpd="sng" algn="ctr">
+                      <a:solidFill>
+                        <a:srgbClr val="E0E0DC"/>
+                      </a:solidFill>
+                      <a:prstDash val="solid"/>
+                      <a:round/>
+                      <a:headEnd type="none" w="med" len="med"/>
+                      <a:tailEnd type="none" w="med" len="med"/>
+                    </a:lnT>
+                    <a:lnB w="6350" cap="flat" cmpd="sng" algn="ctr">
+                      <a:solidFill>
+                        <a:srgbClr val="E0E0DC"/>
+                      </a:solidFill>
+                      <a:prstDash val="solid"/>
+                      <a:round/>
+                      <a:headEnd type="none" w="med" len="med"/>
+                      <a:tailEnd type="none" w="med" len="med"/>
+                    </a:lnB>
+                    <a:solidFill>
+                      <a:srgbClr val="FFFFFF"/>
+                    </a:solidFill>
+                  </a:tcPr>
+                </a:tc>
+                <a:tc>
+                  <a:txBody>
+                    <a:bodyPr/>
+                    <a:lstStyle/>
+                    <a:p>
+                      <a:pPr marL="0" indent="0" algn="ctr">
+                        <a:buNone/>
+                      </a:pPr>
+                      <a:r>
+                        <a:rPr lang="en-US" sz="900" b="1" dirty="0">
+                          <a:solidFill>
+                            <a:srgbClr val="4D4D4D"/>
+                          </a:solidFill>
+                          <a:latin typeface="Calibri" pitchFamily="34" charset="0"/>
+                          <a:ea typeface="Calibri" pitchFamily="34" charset="-122"/>
+                          <a:cs typeface="Calibri" pitchFamily="34" charset="-120"/>
+                        </a:rPr>
+                        <a:t>6 600 zł</a:t>
+                      </a:r>
+                      <a:endParaRPr lang="en-US" sz="900" dirty="0">
+                        <a:latin typeface="Calibri" charset="0"/>
+                        <a:ea typeface="Calibri" charset="0"/>
+                        <a:cs typeface="Calibri" charset="0"/>
+                      </a:endParaRPr>
+                    </a:p>
+                  </a:txBody>
+                  <a:tcPr marL="64008" marR="64008" marT="27432" marB="27432" anchor="ctr">
+                    <a:lnL w="6350" cap="flat" cmpd="sng" algn="ctr">
+                      <a:solidFill>
+                        <a:srgbClr val="E0E0DC"/>
+                      </a:solidFill>
+                      <a:prstDash val="solid"/>
+                      <a:round/>
+                      <a:headEnd type="none" w="med" len="med"/>
+                      <a:tailEnd type="none" w="med" len="med"/>
+                    </a:lnL>
+                    <a:lnR w="6350" cap="flat" cmpd="sng" algn="ctr">
+                      <a:solidFill>
+                        <a:srgbClr val="E0E0DC"/>
+                      </a:solidFill>
+                      <a:prstDash val="solid"/>
+                      <a:round/>
+                      <a:headEnd type="none" w="med" len="med"/>
+                      <a:tailEnd type="none" w="med" len="med"/>
+                    </a:lnR>
+                    <a:lnT w="6350" cap="flat" cmpd="sng" algn="ctr">
+                      <a:solidFill>
+                        <a:srgbClr val="E0E0DC"/>
+                      </a:solidFill>
+                      <a:prstDash val="solid"/>
+                      <a:round/>
+                      <a:headEnd type="none" w="med" len="med"/>
+                      <a:tailEnd type="none" w="med" len="med"/>
+                    </a:lnT>
+                    <a:lnB w="6350" cap="flat" cmpd="sng" algn="ctr">
+                      <a:solidFill>
+                        <a:srgbClr val="E0E0DC"/>
+                      </a:solidFill>
+                      <a:prstDash val="solid"/>
+                      <a:round/>
+                      <a:headEnd type="none" w="med" len="med"/>
+                      <a:tailEnd type="none" w="med" len="med"/>
+                    </a:lnB>
+                    <a:solidFill>
+                      <a:srgbClr val="FFFFFF"/>
+                    </a:solidFill>
+                  </a:tcPr>
+                </a:tc>
+                <a:tc>
+                  <a:txBody>
+                    <a:bodyPr/>
+                    <a:lstStyle/>
+                    <a:p>
+                      <a:pPr marL="0" indent="0" algn="l">
+                        <a:buNone/>
+                      </a:pPr>
+                      <a:r>
+                        <a:rPr lang="en-US" sz="900" dirty="0">
+                          <a:solidFill>
+                            <a:srgbClr val="4D4D4D"/>
+                          </a:solidFill>
+                          <a:latin typeface="Calibri" pitchFamily="34" charset="0"/>
+                          <a:ea typeface="Calibri" pitchFamily="34" charset="-122"/>
+                          <a:cs typeface="Calibri" pitchFamily="34" charset="-120"/>
+                        </a:rPr>
+                        <a:t>strona docelowa kampanii z pomiarem konwersji</a:t>
+                      </a:r>
+                      <a:endParaRPr lang="en-US" sz="900" dirty="0">
+                        <a:latin typeface="Calibri" charset="0"/>
+                        <a:ea typeface="Calibri" charset="0"/>
+                        <a:cs typeface="Calibri" charset="0"/>
+                      </a:endParaRPr>
+                    </a:p>
+                  </a:txBody>
+                  <a:tcPr marL="64008" marR="64008" marT="27432" marB="27432" anchor="ctr">
+                    <a:lnL w="6350" cap="flat" cmpd="sng" algn="ctr">
+                      <a:solidFill>
+                        <a:srgbClr val="E0E0DC"/>
+                      </a:solidFill>
+                      <a:prstDash val="solid"/>
+                      <a:round/>
+                      <a:headEnd type="none" w="med" len="med"/>
+                      <a:tailEnd type="none" w="med" len="med"/>
+                    </a:lnL>
+                    <a:lnR w="6350" cap="flat" cmpd="sng" algn="ctr">
+                      <a:solidFill>
+                        <a:srgbClr val="E0E0DC"/>
+                      </a:solidFill>
+                      <a:prstDash val="solid"/>
+                      <a:round/>
+                      <a:headEnd type="none" w="med" len="med"/>
+                      <a:tailEnd type="none" w="med" len="med"/>
+                    </a:lnR>
+                    <a:lnT w="6350" cap="flat" cmpd="sng" algn="ctr">
+                      <a:solidFill>
+                        <a:srgbClr val="E0E0DC"/>
+                      </a:solidFill>
+                      <a:prstDash val="solid"/>
+                      <a:round/>
+                      <a:headEnd type="none" w="med" len="med"/>
+                      <a:tailEnd type="none" w="med" len="med"/>
+                    </a:lnT>
+                    <a:lnB w="6350" cap="flat" cmpd="sng" algn="ctr">
+                      <a:solidFill>
+                        <a:srgbClr val="E0E0DC"/>
+                      </a:solidFill>
+                      <a:prstDash val="solid"/>
+                      <a:round/>
+                      <a:headEnd type="none" w="med" len="med"/>
+                      <a:tailEnd type="none" w="med" len="med"/>
+                    </a:lnB>
+                    <a:solidFill>
+                      <a:srgbClr val="FFFFFF"/>
+                    </a:solidFill>
+                  </a:tcPr>
+                </a:tc>
+              </a:tr>
+              <a:tr h="228600">
+                <a:tc>
+                  <a:txBody>
+                    <a:bodyPr/>
+                    <a:lstStyle/>
+                    <a:p>
+                      <a:pPr marL="0" indent="0" algn="l">
+                        <a:buNone/>
+                      </a:pPr>
+                      <a:r>
+                        <a:rPr lang="en-US" sz="900" b="1" dirty="0">
+                          <a:solidFill>
+                            <a:srgbClr val="111111"/>
+                          </a:solidFill>
+                          <a:latin typeface="Calibri" pitchFamily="34" charset="0"/>
+                          <a:ea typeface="Calibri" pitchFamily="34" charset="-122"/>
+                          <a:cs typeface="Calibri" pitchFamily="34" charset="-120"/>
+                        </a:rPr>
+                        <a:t>Content</a:t>
+                      </a:r>
+                      <a:endParaRPr lang="en-US" sz="900" dirty="0">
+                        <a:latin typeface="Calibri" charset="0"/>
+                        <a:ea typeface="Calibri" charset="0"/>
+                        <a:cs typeface="Calibri" charset="0"/>
+                      </a:endParaRPr>
+                    </a:p>
+                  </a:txBody>
+                  <a:tcPr marL="64008" marR="64008" marT="27432" marB="27432" anchor="ctr">
+                    <a:lnL w="6350" cap="flat" cmpd="sng" algn="ctr">
+                      <a:solidFill>
+                        <a:srgbClr val="E0E0DC"/>
+                      </a:solidFill>
+                      <a:prstDash val="solid"/>
+                      <a:round/>
+                      <a:headEnd type="none" w="med" len="med"/>
+                      <a:tailEnd type="none" w="med" len="med"/>
+                    </a:lnL>
+                    <a:lnR w="6350" cap="flat" cmpd="sng" algn="ctr">
+                      <a:solidFill>
+                        <a:srgbClr val="E0E0DC"/>
+                      </a:solidFill>
+                      <a:prstDash val="solid"/>
+                      <a:round/>
+                      <a:headEnd type="none" w="med" len="med"/>
+                      <a:tailEnd type="none" w="med" len="med"/>
+                    </a:lnR>
+                    <a:lnT w="6350" cap="flat" cmpd="sng" algn="ctr">
+                      <a:solidFill>
+                        <a:srgbClr val="E0E0DC"/>
+                      </a:solidFill>
+                      <a:prstDash val="solid"/>
+                      <a:round/>
+                      <a:headEnd type="none" w="med" len="med"/>
+                      <a:tailEnd type="none" w="med" len="med"/>
+                    </a:lnT>
+                    <a:lnB w="6350" cap="flat" cmpd="sng" algn="ctr">
+                      <a:solidFill>
+                        <a:srgbClr val="E0E0DC"/>
+                      </a:solidFill>
+                      <a:prstDash val="solid"/>
+                      <a:round/>
+                      <a:headEnd type="none" w="med" len="med"/>
+                      <a:tailEnd type="none" w="med" len="med"/>
+                    </a:lnB>
+                    <a:solidFill>
+                      <a:srgbClr val="FFFFFF"/>
+                    </a:solidFill>
+                  </a:tcPr>
+                </a:tc>
+                <a:tc>
+                  <a:txBody>
+                    <a:bodyPr/>
+                    <a:lstStyle/>
+                    <a:p>
+                      <a:pPr marL="0" indent="0" algn="ctr">
+                        <a:buNone/>
+                      </a:pPr>
+                      <a:r>
+                        <a:rPr lang="en-US" sz="900" b="1" dirty="0">
+                          <a:solidFill>
+                            <a:srgbClr val="4D4D4D"/>
+                          </a:solidFill>
+                          <a:latin typeface="Calibri" pitchFamily="34" charset="0"/>
+                          <a:ea typeface="Calibri" pitchFamily="34" charset="-122"/>
+                          <a:cs typeface="Calibri" pitchFamily="34" charset="-120"/>
+                        </a:rPr>
+                        <a:t>2 000 zł</a:t>
+                      </a:r>
+                      <a:endParaRPr lang="en-US" sz="900" dirty="0">
+                        <a:latin typeface="Calibri" charset="0"/>
+                        <a:ea typeface="Calibri" charset="0"/>
+                        <a:cs typeface="Calibri" charset="0"/>
+                      </a:endParaRPr>
+                    </a:p>
+                  </a:txBody>
+                  <a:tcPr marL="64008" marR="64008" marT="27432" marB="27432" anchor="ctr">
+                    <a:lnL w="6350" cap="flat" cmpd="sng" algn="ctr">
+                      <a:solidFill>
+                        <a:srgbClr val="E0E0DC"/>
+                      </a:solidFill>
+                      <a:prstDash val="solid"/>
+                      <a:round/>
+                      <a:headEnd type="none" w="med" len="med"/>
+                      <a:tailEnd type="none" w="med" len="med"/>
+                    </a:lnL>
+                    <a:lnR w="6350" cap="flat" cmpd="sng" algn="ctr">
+                      <a:solidFill>
+                        <a:srgbClr val="E0E0DC"/>
+                      </a:solidFill>
+                      <a:prstDash val="solid"/>
+                      <a:round/>
+                      <a:headEnd type="none" w="med" len="med"/>
+                      <a:tailEnd type="none" w="med" len="med"/>
+                    </a:lnR>
+                    <a:lnT w="6350" cap="flat" cmpd="sng" algn="ctr">
+                      <a:solidFill>
+                        <a:srgbClr val="E0E0DC"/>
+                      </a:solidFill>
+                      <a:prstDash val="solid"/>
+                      <a:round/>
+                      <a:headEnd type="none" w="med" len="med"/>
+                      <a:tailEnd type="none" w="med" len="med"/>
+                    </a:lnT>
+                    <a:lnB w="6350" cap="flat" cmpd="sng" algn="ctr">
+                      <a:solidFill>
+                        <a:srgbClr val="E0E0DC"/>
+                      </a:solidFill>
+                      <a:prstDash val="solid"/>
+                      <a:round/>
+                      <a:headEnd type="none" w="med" len="med"/>
+                      <a:tailEnd type="none" w="med" len="med"/>
+                    </a:lnB>
+                    <a:solidFill>
+                      <a:srgbClr val="FFFFFF"/>
+                    </a:solidFill>
+                  </a:tcPr>
+                </a:tc>
+                <a:tc>
+                  <a:txBody>
+                    <a:bodyPr/>
+                    <a:lstStyle/>
+                    <a:p>
+                      <a:pPr marL="0" indent="0" algn="l">
+                        <a:buNone/>
+                      </a:pPr>
+                      <a:r>
+                        <a:rPr lang="en-US" sz="900" dirty="0">
+                          <a:solidFill>
+                            <a:srgbClr val="4D4D4D"/>
+                          </a:solidFill>
+                          <a:latin typeface="Calibri" pitchFamily="34" charset="0"/>
+                          <a:ea typeface="Calibri" pitchFamily="34" charset="-122"/>
+                          <a:cs typeface="Calibri" pitchFamily="34" charset="-120"/>
+                        </a:rPr>
+                        <a:t>treści na landing page i do kanałów kampanii</a:t>
+                      </a:r>
+                      <a:endParaRPr lang="en-US" sz="900" dirty="0">
+                        <a:latin typeface="Calibri" charset="0"/>
+                        <a:ea typeface="Calibri" charset="0"/>
+                        <a:cs typeface="Calibri" charset="0"/>
+                      </a:endParaRPr>
+                    </a:p>
+                  </a:txBody>
+                  <a:tcPr marL="64008" marR="64008" marT="27432" marB="27432" anchor="ctr">
+                    <a:lnL w="6350" cap="flat" cmpd="sng" algn="ctr">
+                      <a:solidFill>
+                        <a:srgbClr val="E0E0DC"/>
+                      </a:solidFill>
+                      <a:prstDash val="solid"/>
+                      <a:round/>
+                      <a:headEnd type="none" w="med" len="med"/>
+                      <a:tailEnd type="none" w="med" len="med"/>
+                    </a:lnL>
+                    <a:lnR w="6350" cap="flat" cmpd="sng" algn="ctr">
+                      <a:solidFill>
+                        <a:srgbClr val="E0E0DC"/>
+                      </a:solidFill>
+                      <a:prstDash val="solid"/>
+                      <a:round/>
+                      <a:headEnd type="none" w="med" len="med"/>
+                      <a:tailEnd type="none" w="med" len="med"/>
+                    </a:lnR>
+                    <a:lnT w="6350" cap="flat" cmpd="sng" algn="ctr">
+                      <a:solidFill>
+                        <a:srgbClr val="E0E0DC"/>
+                      </a:solidFill>
+                      <a:prstDash val="solid"/>
+                      <a:round/>
+                      <a:headEnd type="none" w="med" len="med"/>
+                      <a:tailEnd type="none" w="med" len="med"/>
+                    </a:lnT>
+                    <a:lnB w="6350" cap="flat" cmpd="sng" algn="ctr">
+                      <a:solidFill>
+                        <a:srgbClr val="E0E0DC"/>
+                      </a:solidFill>
+                      <a:prstDash val="solid"/>
+                      <a:round/>
+                      <a:headEnd type="none" w="med" len="med"/>
+                      <a:tailEnd type="none" w="med" len="med"/>
+                    </a:lnB>
+                    <a:solidFill>
+                      <a:srgbClr val="FFFFFF"/>
+                    </a:solidFill>
+                  </a:tcPr>
+                </a:tc>
+              </a:tr>
+              <a:tr h="228600">
+                <a:tc>
+                  <a:txBody>
+                    <a:bodyPr/>
+                    <a:lstStyle/>
+                    <a:p>
+                      <a:pPr marL="0" indent="0" algn="l">
+                        <a:buNone/>
+                      </a:pPr>
+                      <a:r>
+                        <a:rPr lang="en-US" sz="900" b="1" dirty="0">
+                          <a:solidFill>
+                            <a:srgbClr val="111111"/>
+                          </a:solidFill>
+                          <a:latin typeface="Calibri" pitchFamily="34" charset="0"/>
+                          <a:ea typeface="Calibri" pitchFamily="34" charset="-122"/>
+                          <a:cs typeface="Calibri" pitchFamily="34" charset="-120"/>
+                        </a:rPr>
+                        <a:t>Fee agencyjne – 10% kosztów zewnętrznych</a:t>
+                      </a:r>
+                      <a:endParaRPr lang="en-US" sz="900" dirty="0">
+                        <a:latin typeface="Calibri" charset="0"/>
+                        <a:ea typeface="Calibri" charset="0"/>
+                        <a:cs typeface="Calibri" charset="0"/>
+                      </a:endParaRPr>
+                    </a:p>
+                  </a:txBody>
+                  <a:tcPr marL="64008" marR="64008" marT="27432" marB="27432" anchor="ctr">
+                    <a:lnL w="6350" cap="flat" cmpd="sng" algn="ctr">
+                      <a:solidFill>
+                        <a:srgbClr val="E0E0DC"/>
+                      </a:solidFill>
+                      <a:prstDash val="solid"/>
+                      <a:round/>
+                      <a:headEnd type="none" w="med" len="med"/>
+                      <a:tailEnd type="none" w="med" len="med"/>
+                    </a:lnL>
+                    <a:lnR w="6350" cap="flat" cmpd="sng" algn="ctr">
+                      <a:solidFill>
+                        <a:srgbClr val="E0E0DC"/>
+                      </a:solidFill>
+                      <a:prstDash val="solid"/>
+                      <a:round/>
+                      <a:headEnd type="none" w="med" len="med"/>
+                      <a:tailEnd type="none" w="med" len="med"/>
+                    </a:lnR>
+                    <a:lnT w="6350" cap="flat" cmpd="sng" algn="ctr">
+                      <a:solidFill>
+                        <a:srgbClr val="E0E0DC"/>
+                      </a:solidFill>
+                      <a:prstDash val="solid"/>
+                      <a:round/>
+                      <a:headEnd type="none" w="med" len="med"/>
+                      <a:tailEnd type="none" w="med" len="med"/>
+                    </a:lnT>
+                    <a:lnB w="6350" cap="flat" cmpd="sng" algn="ctr">
+                      <a:solidFill>
+                        <a:srgbClr val="E0E0DC"/>
+                      </a:solidFill>
+                      <a:prstDash val="solid"/>
+                      <a:round/>
+                      <a:headEnd type="none" w="med" len="med"/>
+                      <a:tailEnd type="none" w="med" len="med"/>
+                    </a:lnB>
+                    <a:solidFill>
+                      <a:srgbClr val="FFFFFF"/>
+                    </a:solidFill>
+                  </a:tcPr>
+                </a:tc>
+                <a:tc>
+                  <a:txBody>
+                    <a:bodyPr/>
+                    <a:lstStyle/>
+                    <a:p>
+                      <a:pPr marL="0" indent="0" algn="ctr">
+                        <a:buNone/>
+                      </a:pPr>
+                      <a:r>
+                        <a:rPr lang="en-US" sz="900" b="1" dirty="0">
+                          <a:solidFill>
+                            <a:srgbClr val="4D4D4D"/>
+                          </a:solidFill>
+                          <a:latin typeface="Calibri" pitchFamily="34" charset="0"/>
+                          <a:ea typeface="Calibri" pitchFamily="34" charset="-122"/>
+                          <a:cs typeface="Calibri" pitchFamily="34" charset="-120"/>
+                        </a:rPr>
+                        <a:t>15 900–16 200 zł</a:t>
+                      </a:r>
+                      <a:endParaRPr lang="en-US" sz="900" dirty="0">
+                        <a:latin typeface="Calibri" charset="0"/>
+                        <a:ea typeface="Calibri" charset="0"/>
+                        <a:cs typeface="Calibri" charset="0"/>
+                      </a:endParaRPr>
+                    </a:p>
+                  </a:txBody>
+                  <a:tcPr marL="64008" marR="64008" marT="27432" marB="27432" anchor="ctr">
+                    <a:lnL w="6350" cap="flat" cmpd="sng" algn="ctr">
+                      <a:solidFill>
+                        <a:srgbClr val="E0E0DC"/>
+                      </a:solidFill>
+                      <a:prstDash val="solid"/>
+                      <a:round/>
+                      <a:headEnd type="none" w="med" len="med"/>
+                      <a:tailEnd type="none" w="med" len="med"/>
+                    </a:lnL>
+                    <a:lnR w="6350" cap="flat" cmpd="sng" algn="ctr">
+                      <a:solidFill>
+                        <a:srgbClr val="E0E0DC"/>
+                      </a:solidFill>
+                      <a:prstDash val="solid"/>
+                      <a:round/>
+                      <a:headEnd type="none" w="med" len="med"/>
+                      <a:tailEnd type="none" w="med" len="med"/>
+                    </a:lnR>
+                    <a:lnT w="6350" cap="flat" cmpd="sng" algn="ctr">
+                      <a:solidFill>
+                        <a:srgbClr val="E0E0DC"/>
+                      </a:solidFill>
+                      <a:prstDash val="solid"/>
+                      <a:round/>
+                      <a:headEnd type="none" w="med" len="med"/>
+                      <a:tailEnd type="none" w="med" len="med"/>
+                    </a:lnT>
+                    <a:lnB w="6350" cap="flat" cmpd="sng" algn="ctr">
+                      <a:solidFill>
+                        <a:srgbClr val="E0E0DC"/>
+                      </a:solidFill>
+                      <a:prstDash val="solid"/>
+                      <a:round/>
+                      <a:headEnd type="none" w="med" len="med"/>
+                      <a:tailEnd type="none" w="med" len="med"/>
+                    </a:lnB>
+                    <a:solidFill>
+                      <a:srgbClr val="FFFFFF"/>
+                    </a:solidFill>
+                  </a:tcPr>
+                </a:tc>
+                <a:tc>
+                  <a:txBody>
+                    <a:bodyPr/>
+                    <a:lstStyle/>
+                    <a:p>
+                      <a:pPr marL="0" indent="0" algn="l">
+                        <a:buNone/>
+                      </a:pPr>
+                      <a:r>
+                        <a:rPr lang="en-US" sz="900" dirty="0">
+                          <a:solidFill>
+                            <a:srgbClr val="4D4D4D"/>
+                          </a:solidFill>
+                          <a:latin typeface="Calibri" pitchFamily="34" charset="0"/>
+                          <a:ea typeface="Calibri" pitchFamily="34" charset="-122"/>
+                          <a:cs typeface="Calibri" pitchFamily="34" charset="-120"/>
+                        </a:rPr>
+                        <a:t>wyłącznie od budowy i aranżacji budki oraz wynagrodzeń influencerów</a:t>
+                      </a:r>
+                      <a:endParaRPr lang="en-US" sz="900" dirty="0">
+                        <a:latin typeface="Calibri" charset="0"/>
+                        <a:ea typeface="Calibri" charset="0"/>
+                        <a:cs typeface="Calibri" charset="0"/>
+                      </a:endParaRPr>
+                    </a:p>
+                  </a:txBody>
+                  <a:tcPr marL="64008" marR="64008" marT="27432" marB="27432" anchor="ctr">
+                    <a:lnL w="6350" cap="flat" cmpd="sng" algn="ctr">
+                      <a:solidFill>
+                        <a:srgbClr val="E0E0DC"/>
+                      </a:solidFill>
+                      <a:prstDash val="solid"/>
+                      <a:round/>
+                      <a:headEnd type="none" w="med" len="med"/>
+                      <a:tailEnd type="none" w="med" len="med"/>
+                    </a:lnL>
+                    <a:lnR w="6350" cap="flat" cmpd="sng" algn="ctr">
+                      <a:solidFill>
+                        <a:srgbClr val="E0E0DC"/>
+                      </a:solidFill>
+                      <a:prstDash val="solid"/>
+                      <a:round/>
+                      <a:headEnd type="none" w="med" len="med"/>
+                      <a:tailEnd type="none" w="med" len="med"/>
+                    </a:lnR>
+                    <a:lnT w="6350" cap="flat" cmpd="sng" algn="ctr">
+                      <a:solidFill>
+                        <a:srgbClr val="E0E0DC"/>
+                      </a:solidFill>
+                      <a:prstDash val="solid"/>
+                      <a:round/>
+                      <a:headEnd type="none" w="med" len="med"/>
+                      <a:tailEnd type="none" w="med" len="med"/>
+                    </a:lnT>
+                    <a:lnB w="6350" cap="flat" cmpd="sng" algn="ctr">
+                      <a:solidFill>
+                        <a:srgbClr val="E0E0DC"/>
+                      </a:solidFill>
+                      <a:prstDash val="solid"/>
+                      <a:round/>
+                      <a:headEnd type="none" w="med" len="med"/>
+                      <a:tailEnd type="none" w="med" len="med"/>
+                    </a:lnB>
+                    <a:solidFill>
+                      <a:srgbClr val="FFFFFF"/>
+                    </a:solidFill>
+                  </a:tcPr>
+                </a:tc>
+              </a:tr>
+              <a:tr h="274320">
+                <a:tc>
+                  <a:txBody>
+                    <a:bodyPr/>
+                    <a:lstStyle/>
+                    <a:p>
+                      <a:pPr marL="0" indent="0" algn="l">
+                        <a:buNone/>
+                      </a:pPr>
+                      <a:r>
+                        <a:rPr lang="en-US" sz="950" b="1" dirty="0">
+                          <a:solidFill>
+                            <a:srgbClr val="111111"/>
+                          </a:solidFill>
+                          <a:latin typeface="Calibri" pitchFamily="34" charset="0"/>
+                          <a:ea typeface="Calibri" pitchFamily="34" charset="-122"/>
+                          <a:cs typeface="Calibri" pitchFamily="34" charset="-120"/>
+                        </a:rPr>
+                        <a:t>RAZEM (netto)</a:t>
+                      </a:r>
+                      <a:endParaRPr lang="en-US" sz="950" dirty="0">
+                        <a:latin typeface="Calibri" charset="0"/>
+                        <a:ea typeface="Calibri" charset="0"/>
+                        <a:cs typeface="Calibri" charset="0"/>
+                      </a:endParaRPr>
+                    </a:p>
+                  </a:txBody>
+                  <a:tcPr marL="64008" marR="64008" marT="27432" marB="27432" anchor="ctr">
+                    <a:lnL w="6350" cap="flat" cmpd="sng" algn="ctr">
+                      <a:solidFill>
+                        <a:srgbClr val="E0E0DC"/>
+                      </a:solidFill>
+                      <a:prstDash val="solid"/>
+                      <a:round/>
+                      <a:headEnd type="none" w="med" len="med"/>
+                      <a:tailEnd type="none" w="med" len="med"/>
+                    </a:lnL>
+                    <a:lnR w="6350" cap="flat" cmpd="sng" algn="ctr">
+                      <a:solidFill>
+                        <a:srgbClr val="E0E0DC"/>
+                      </a:solidFill>
+                      <a:prstDash val="solid"/>
+                      <a:round/>
+                      <a:headEnd type="none" w="med" len="med"/>
+                      <a:tailEnd type="none" w="med" len="med"/>
+                    </a:lnR>
+                    <a:lnT w="6350" cap="flat" cmpd="sng" algn="ctr">
+                      <a:solidFill>
+                        <a:srgbClr val="E0E0DC"/>
+                      </a:solidFill>
+                      <a:prstDash val="solid"/>
+                      <a:round/>
+                      <a:headEnd type="none" w="med" len="med"/>
+                      <a:tailEnd type="none" w="med" len="med"/>
+                    </a:lnT>
+                    <a:lnB w="6350" cap="flat" cmpd="sng" algn="ctr">
+                      <a:solidFill>
+                        <a:srgbClr val="E0E0DC"/>
+                      </a:solidFill>
+                      <a:prstDash val="solid"/>
+                      <a:round/>
+                      <a:headEnd type="none" w="med" len="med"/>
+                      <a:tailEnd type="none" w="med" len="med"/>
+                    </a:lnB>
+                    <a:solidFill>
+                      <a:srgbClr val="FFF3C6"/>
+                    </a:solidFill>
+                  </a:tcPr>
+                </a:tc>
+                <a:tc>
+                  <a:txBody>
+                    <a:bodyPr/>
+                    <a:lstStyle/>
+                    <a:p>
+                      <a:pPr marL="0" indent="0" algn="ctr">
+                        <a:buNone/>
+                      </a:pPr>
+                      <a:r>
+                        <a:rPr lang="en-US" sz="950" b="1" dirty="0">
+                          <a:solidFill>
+                            <a:srgbClr val="111111"/>
+                          </a:solidFill>
+                          <a:latin typeface="Calibri" pitchFamily="34" charset="0"/>
+                          <a:ea typeface="Calibri" pitchFamily="34" charset="-122"/>
+                          <a:cs typeface="Calibri" pitchFamily="34" charset="-120"/>
+                        </a:rPr>
+                        <a:t>693 000–696 300 zł</a:t>
+                      </a:r>
+                      <a:endParaRPr lang="en-US" sz="950" dirty="0">
+                        <a:latin typeface="Calibri" charset="0"/>
+                        <a:ea typeface="Calibri" charset="0"/>
+                        <a:cs typeface="Calibri" charset="0"/>
+                      </a:endParaRPr>
+                    </a:p>
+                  </a:txBody>
+                  <a:tcPr marL="64008" marR="64008" marT="27432" marB="27432" anchor="ctr">
+                    <a:lnL w="6350" cap="flat" cmpd="sng" algn="ctr">
+                      <a:solidFill>
+                        <a:srgbClr val="E0E0DC"/>
+                      </a:solidFill>
+                      <a:prstDash val="solid"/>
+                      <a:round/>
+                      <a:headEnd type="none" w="med" len="med"/>
+                      <a:tailEnd type="none" w="med" len="med"/>
+                    </a:lnL>
+                    <a:lnR w="6350" cap="flat" cmpd="sng" algn="ctr">
+                      <a:solidFill>
+                        <a:srgbClr val="E0E0DC"/>
+                      </a:solidFill>
+                      <a:prstDash val="solid"/>
+                      <a:round/>
+                      <a:headEnd type="none" w="med" len="med"/>
+                      <a:tailEnd type="none" w="med" len="med"/>
+                    </a:lnR>
+                    <a:lnT w="6350" cap="flat" cmpd="sng" algn="ctr">
+                      <a:solidFill>
+                        <a:srgbClr val="E0E0DC"/>
+                      </a:solidFill>
+                      <a:prstDash val="solid"/>
+                      <a:round/>
+                      <a:headEnd type="none" w="med" len="med"/>
+                      <a:tailEnd type="none" w="med" len="med"/>
+                    </a:lnT>
+                    <a:lnB w="6350" cap="flat" cmpd="sng" algn="ctr">
+                      <a:solidFill>
+                        <a:srgbClr val="E0E0DC"/>
+                      </a:solidFill>
+                      <a:prstDash val="solid"/>
+                      <a:round/>
+                      <a:headEnd type="none" w="med" len="med"/>
+                      <a:tailEnd type="none" w="med" len="med"/>
+                    </a:lnB>
+                    <a:solidFill>
+                      <a:srgbClr val="FFF3C6"/>
+                    </a:solidFill>
+                  </a:tcPr>
+                </a:tc>
+                <a:tc>
+                  <a:txBody>
+                    <a:bodyPr/>
+                    <a:lstStyle/>
+                    <a:p>
+                      <a:pPr marL="0" indent="0" algn="l">
+                        <a:buNone/>
+                      </a:pPr>
+                      <a:endParaRPr lang="en-US" sz="950" dirty="0">
+                        <a:latin typeface="Calibri" charset="0"/>
+                        <a:ea typeface="Calibri" charset="0"/>
+                        <a:cs typeface="Calibri" charset="0"/>
+                      </a:endParaRPr>
+                    </a:p>
+                  </a:txBody>
+                  <a:tcPr marL="64008" marR="64008" marT="27432" marB="27432" anchor="ctr">
+                    <a:lnL w="6350" cap="flat" cmpd="sng" algn="ctr">
+                      <a:solidFill>
+                        <a:srgbClr val="E0E0DC"/>
+                      </a:solidFill>
+                      <a:prstDash val="solid"/>
+                      <a:round/>
+                      <a:headEnd type="none" w="med" len="med"/>
+                      <a:tailEnd type="none" w="med" len="med"/>
+                    </a:lnL>
+                    <a:lnR w="6350" cap="flat" cmpd="sng" algn="ctr">
+                      <a:solidFill>
+                        <a:srgbClr val="E0E0DC"/>
+                      </a:solidFill>
+                      <a:prstDash val="solid"/>
+                      <a:round/>
+                      <a:headEnd type="none" w="med" len="med"/>
+                      <a:tailEnd type="none" w="med" len="med"/>
+                    </a:lnR>
+                    <a:lnT w="6350" cap="flat" cmpd="sng" algn="ctr">
+                      <a:solidFill>
+                        <a:srgbClr val="E0E0DC"/>
+                      </a:solidFill>
+                      <a:prstDash val="solid"/>
+                      <a:round/>
+                      <a:headEnd type="none" w="med" len="med"/>
+                      <a:tailEnd type="none" w="med" len="med"/>
+                    </a:lnT>
+                    <a:lnB w="6350" cap="flat" cmpd="sng" algn="ctr">
+                      <a:solidFill>
+                        <a:srgbClr val="E0E0DC"/>
+                      </a:solidFill>
+                      <a:prstDash val="solid"/>
+                      <a:round/>
+                      <a:headEnd type="none" w="med" len="med"/>
+                      <a:tailEnd type="none" w="med" len="med"/>
+                    </a:lnB>
+                    <a:solidFill>
+                      <a:srgbClr val="FFF3C6"/>
+                    </a:solidFill>
+                  </a:tcPr>
+                </a:tc>
+              </a:tr>
+            </a:tbl>
+          </a:graphicData>
+        </a:graphic>
+      </p:graphicFrame>
+      <p:sp>
+        <p:nvSpPr>
+          <p:cNvPr id="7" name="Shape 2"/>
+          <p:cNvSpPr/>
+          <p:nvPr/>
+        </p:nvSpPr>
+        <p:spPr>
+          <a:xfrm>
+            <a:off x="1691640" y="5394960"/>
+            <a:ext cx="9692640" cy="1280160"/>
+          </a:xfrm>
+          <a:prstGeom prst="roundRect">
+            <a:avLst>
+              <a:gd name="adj" fmla="val 4444"/>
+            </a:avLst>
+          </a:prstGeom>
+          <a:solidFill>
+            <a:srgbClr val="FFF3C6">
+              <a:alpha val="45000"/>
+            </a:srgbClr>
+          </a:solidFill>
+          <a:ln w="9525">
+            <a:solidFill>
+              <a:srgbClr val="F0A500"/>
+            </a:solidFill>
+            <a:prstDash val="solid"/>
+          </a:ln>
+        </p:spPr>
+      </p:sp>
+      <p:sp>
+        <p:nvSpPr>
+          <p:cNvPr id="8" name="Text 3"/>
+          <p:cNvSpPr/>
+          <p:nvPr/>
+        </p:nvSpPr>
+        <p:spPr>
+          <a:xfrm>
+            <a:off x="1874520" y="5486400"/>
+            <a:ext cx="9326880" cy="1097280"/>
+          </a:xfrm>
+          <a:prstGeom prst="rect">
+            <a:avLst/>
+          </a:prstGeom>
+          <a:noFill/>
+          <a:ln/>
+        </p:spPr>
+        <p:txBody>
+          <a:bodyPr wrap="square" lIns="0" tIns="0" rIns="0" bIns="0" rtlCol="0" anchor="ctr"/>
+          <a:lstStyle/>
+          <a:p>
+            <a:pPr marL="0" indent="0">
+              <a:buNone/>
+            </a:pPr>
+            <a:r>
+              <a:rPr lang="en-US" sz="1000" dirty="0">
+                <a:solidFill>
+                  <a:srgbClr val="111111"/>
+                </a:solidFill>
+                <a:latin typeface="Arial Black" pitchFamily="34" charset="0"/>
+                <a:ea typeface="Arial Black" pitchFamily="34" charset="-122"/>
+                <a:cs typeface="Arial Black" pitchFamily="34" charset="-120"/>
+              </a:rPr>
+              <a:t>Zasady rozliczenia:  </a:t>
+            </a:r>
+            <a:r>
+              <a:rPr lang="en-US" sz="1000" dirty="0">
+                <a:solidFill>
+                  <a:srgbClr val="111111"/>
+                </a:solidFill>
+                <a:latin typeface="Calibri" pitchFamily="34" charset="0"/>
+                <a:ea typeface="Calibri" pitchFamily="34" charset="-122"/>
+                <a:cs typeface="Calibri" pitchFamily="34" charset="-120"/>
+              </a:rPr>
+              <a:t>Fee agencyjne 10% naliczamy wyłącznie od kosztów zewnętrznych: budowy i aranżacji budki oraz wynagrodzeń influencerów (fee mediowe ujęte przy mediach). Zestawienie nie obejmuje najmu powierzchni w Arkadii (210 tys. zł netto / 2 tyg.), obsługi hostess, filmów wiralowych i akcji CSR – te pozycje ujęte są w budżecie całkowitym kampanii.</a:t>
+            </a:r>
+            <a:endParaRPr lang="en-US" sz="1000" dirty="0"/>
+          </a:p>
+        </p:txBody>
+      </p:sp>
+    </p:spTree>
   </p:cSld>
   <p:clrMapOvr>
     <a:masterClrMapping/>

</xml_diff>